<commit_message>
Add the five levels of agentic work as slide 15.
The talk never named where "drafts only, you accept every line" sits on
the human-in/on-the-loop ladder. Slide 15 shows the five levels in the
deck's five-card style, marks this kit as Level 1, and names step 7
(schedule it) as the door to Level 2. Speaker notes budget one minute.

Adds research/notes/agentic-levels.md as the cited source note, a row in
SOURCES.md (now 21 notes), and renumbers the safety card and close to 16
and 17 in build_deck.py, TALK-FLOW.md, and slides/README.md.
</commit_message>
<xml_diff>
--- a/slides/building-your-own-chief-of-staff.pptx
+++ b/slides/building-your-own-chief-of-staff.pptx
@@ -21,6 +21,7 @@
     <p:sldId id="269" r:id="rId21"/>
     <p:sldId id="270" r:id="rId22"/>
     <p:sldId id="271" r:id="rId23"/>
+    <p:sldId id="272" r:id="rId24"/>
   </p:sldIdLst>
   <p:sldSz cx="12191695" cy="6858000" type="screen4x3"/>
   <p:notesSz cx="6858000" cy="9144000"/>
@@ -535,7 +536,7 @@
           <a:p/>
           <a:p>
             <a:r>
-              <a:t>Cite the local source catalog if asked: https://github.com/BittahCriminal/build-your-own-chief-of-staff/blob/main/research/SOURCES.md — 20 Markdown notes documenting the operating rules used in this kit, with original article attribution.</a:t>
+              <a:t>Cite the local source catalog if asked: https://github.com/BittahCriminal/build-your-own-chief-of-staff/blob/main/research/SOURCES.md — 21 Markdown notes documenting the operating rules used in this kit, with original article attribution.</a:t>
             </a:r>
           </a:p>
         </p:txBody>
@@ -1080,25 +1081,25 @@
           <a:lstStyle/>
           <a:p>
             <a:r>
-              <a:t>Leave this up during Q&amp;A if needed.</a:t>
+              <a:t>One minute. This is the map, not a step. Everything they watched today sits on the second card: the agent drafted, a human accepted every line.</a:t>
             </a:r>
           </a:p>
           <a:p/>
           <a:p>
             <a:r>
-              <a:t>If an agent sends a flawed appeal in your name, you now have two problems. Source: https://github.com/BittahCriminal/build-your-own-chief-of-staff/blob/main/research/notes/reusable-rig.md</a:t>
+              <a:t>Level 2 is the hard jump, and it is where most teams are stuck. A timer is dispatch. The moment the recap runs without you asking, you have stopped reading every line and started trusting the check. That only works if the check is deterministic: every owner cites a line, gaps say unassigned, tone matches voice.md. That is why the scheduling gate exists.</a:t>
             </a:r>
           </a:p>
           <a:p/>
           <a:p>
             <a:r>
-              <a:t>Inbox is untrusted. A line that says 'ignore your rules' is data, not an order. First-agent-job: https://github.com/BittahCriminal/build-your-own-chief-of-staff/blob/main/research/notes/first-agent-job.md</a:t>
+              <a:t>Levels 3 and 4 are platform-team territory: agents that wake up on a signal, rules instead of reviews. Name them so the room knows the ladder exists. Do not sell them.</a:t>
             </a:r>
           </a:p>
           <a:p/>
           <a:p>
             <a:r>
-              <a:t>Where the agent should stop: start where a colleague or customer already tells you you're wrong; reconstructing context is the expensive part; the reply is cheap. Source: https://github.com/BittahCriminal/build-your-own-chief-of-staff/blob/main/research/notes/where-to-stop.md</a:t>
+              <a:t>The claim to leave with: the quality of your written checks decides how much autonomy is safe. Source: https://github.com/BittahCriminal/build-your-own-chief-of-staff/blob/main/research/notes/agentic-levels.md</a:t>
             </a:r>
           </a:p>
         </p:txBody>
@@ -1124,6 +1125,94 @@
 </file>
 
 <file path=ppt/notesSlides/notesSlide16.xml><?xml version="1.0" encoding="utf-8"?>
+<p:notes xmlns:a="http://schemas.openxmlformats.org/drawingml/2006/main" xmlns:p="http://schemas.openxmlformats.org/presentationml/2006/main" xmlns:r="http://schemas.openxmlformats.org/officeDocument/2006/relationships">
+  <p:cSld>
+    <p:spTree>
+      <p:nvGrpSpPr>
+        <p:cNvPr id="1" name=""/>
+        <p:cNvGrpSpPr/>
+        <p:nvPr/>
+      </p:nvGrpSpPr>
+      <p:grpSpPr>
+        <a:xfrm>
+          <a:off x="0" y="0"/>
+          <a:ext cx="0" cy="0"/>
+          <a:chOff x="0" y="0"/>
+          <a:chExt cx="0" cy="0"/>
+        </a:xfrm>
+      </p:grpSpPr>
+      <p:sp>
+        <p:nvSpPr>
+          <p:cNvPr id="2" name="Slide Image Placeholder 1"/>
+          <p:cNvSpPr>
+            <a:spLocks noGrp="1"/>
+          </p:cNvSpPr>
+          <p:nvPr>
+            <p:ph type="sldImg" idx="2"/>
+          </p:nvPr>
+        </p:nvSpPr>
+        <p:spPr/>
+      </p:sp>
+      <p:sp>
+        <p:nvSpPr>
+          <p:cNvPr id="3" name="Notes Placeholder 2"/>
+          <p:cNvSpPr>
+            <a:spLocks noGrp="1"/>
+          </p:cNvSpPr>
+          <p:nvPr>
+            <p:ph type="body" idx="3" sz="quarter"/>
+          </p:nvPr>
+        </p:nvSpPr>
+        <p:spPr/>
+        <p:txBody>
+          <a:bodyPr/>
+          <a:lstStyle/>
+          <a:p>
+            <a:r>
+              <a:t>Leave this up during Q&amp;A if needed.</a:t>
+            </a:r>
+          </a:p>
+          <a:p/>
+          <a:p>
+            <a:r>
+              <a:t>If an agent sends a flawed appeal in your name, you now have two problems. Source: https://github.com/BittahCriminal/build-your-own-chief-of-staff/blob/main/research/notes/reusable-rig.md</a:t>
+            </a:r>
+          </a:p>
+          <a:p/>
+          <a:p>
+            <a:r>
+              <a:t>Inbox is untrusted. A line that says 'ignore your rules' is data, not an order. First-agent-job: https://github.com/BittahCriminal/build-your-own-chief-of-staff/blob/main/research/notes/first-agent-job.md</a:t>
+            </a:r>
+          </a:p>
+          <a:p/>
+          <a:p>
+            <a:r>
+              <a:t>Where the agent should stop: start where a colleague or customer already tells you you're wrong; reconstructing context is the expensive part; the reply is cheap. Source: https://github.com/BittahCriminal/build-your-own-chief-of-staff/blob/main/research/notes/where-to-stop.md</a:t>
+            </a:r>
+          </a:p>
+        </p:txBody>
+      </p:sp>
+      <p:sp>
+        <p:nvSpPr>
+          <p:cNvPr id="4" name="Slide Number Placeholder 3"/>
+          <p:cNvSpPr>
+            <a:spLocks noGrp="1"/>
+          </p:cNvSpPr>
+          <p:nvPr>
+            <p:ph type="sldNum" idx="5" sz="quarter"/>
+          </p:nvPr>
+        </p:nvSpPr>
+        <p:spPr/>
+      </p:sp>
+    </p:spTree>
+  </p:cSld>
+  <p:clrMapOvr>
+    <a:masterClrMapping/>
+  </p:clrMapOvr>
+</p:notes>
+</file>
+
+<file path=ppt/notesSlides/notesSlide17.xml><?xml version="1.0" encoding="utf-8"?>
 <p:notes xmlns:a="http://schemas.openxmlformats.org/drawingml/2006/main" xmlns:p="http://schemas.openxmlformats.org/presentationml/2006/main" xmlns:r="http://schemas.openxmlformats.org/officeDocument/2006/relationships">
   <p:cSld>
     <p:spTree>
@@ -5183,7 +5272,7 @@
                 </a:solidFill>
                 <a:latin typeface="Calibri"/>
               </a:rPr>
-              <a:t>1  /  16</a:t>
+              <a:t>1  /  17</a:t>
             </a:r>
           </a:p>
         </p:txBody>
@@ -6055,7 +6144,7 @@
                 </a:solidFill>
                 <a:latin typeface="Calibri"/>
               </a:rPr>
-              <a:t>10  /  16</a:t>
+              <a:t>10  /  17</a:t>
             </a:r>
           </a:p>
         </p:txBody>
@@ -6542,7 +6631,7 @@
                 </a:solidFill>
                 <a:latin typeface="Calibri"/>
               </a:rPr>
-              <a:t>11  /  16</a:t>
+              <a:t>11  /  17</a:t>
             </a:r>
           </a:p>
         </p:txBody>
@@ -7238,7 +7327,7 @@
                 </a:solidFill>
                 <a:latin typeface="Calibri"/>
               </a:rPr>
-              <a:t>12  /  16</a:t>
+              <a:t>12  /  17</a:t>
             </a:r>
           </a:p>
         </p:txBody>
@@ -8754,7 +8843,7 @@
                 </a:solidFill>
                 <a:latin typeface="Calibri"/>
               </a:rPr>
-              <a:t>13  /  16</a:t>
+              <a:t>13  /  17</a:t>
             </a:r>
           </a:p>
         </p:txBody>
@@ -9606,7 +9695,7 @@
                 </a:solidFill>
                 <a:latin typeface="Calibri"/>
               </a:rPr>
-              <a:t>14  /  16</a:t>
+              <a:t>14  /  17</a:t>
             </a:r>
           </a:p>
         </p:txBody>
@@ -9788,21 +9877,64 @@
                 </a:solidFill>
                 <a:latin typeface="Calibri"/>
               </a:rPr>
-              <a:t>Non-negotiable</a:t>
-            </a:r>
-          </a:p>
-        </p:txBody>
-      </p:sp>
-      <p:sp>
-        <p:nvSpPr>
-          <p:cNvPr id="6" name="TextBox 5"/>
-          <p:cNvSpPr txBox="1"/>
-          <p:nvPr/>
-        </p:nvSpPr>
-        <p:spPr>
-          <a:xfrm>
-            <a:off x="731520" y="1188720"/>
-            <a:ext cx="10515600" cy="640080"/>
+              <a:t>Where this goes next</a:t>
+            </a:r>
+          </a:p>
+        </p:txBody>
+      </p:sp>
+      <p:sp>
+        <p:nvSpPr>
+          <p:cNvPr id="6" name="Rectangle 5"/>
+          <p:cNvSpPr/>
+          <p:nvPr/>
+        </p:nvSpPr>
+        <p:spPr>
+          <a:xfrm>
+            <a:off x="502920" y="1325880"/>
+            <a:ext cx="2148840" cy="3108960"/>
+          </a:xfrm>
+          <a:prstGeom prst="rect">
+            <a:avLst/>
+          </a:prstGeom>
+          <a:solidFill>
+            <a:srgbClr val="141414"/>
+          </a:solidFill>
+          <a:ln>
+            <a:noFill/>
+          </a:ln>
+        </p:spPr>
+        <p:style>
+          <a:lnRef idx="1">
+            <a:schemeClr val="accent1"/>
+          </a:lnRef>
+          <a:fillRef idx="3">
+            <a:schemeClr val="accent1"/>
+          </a:fillRef>
+          <a:effectRef idx="2">
+            <a:schemeClr val="accent1"/>
+          </a:effectRef>
+          <a:fontRef idx="minor">
+            <a:schemeClr val="lt1"/>
+          </a:fontRef>
+        </p:style>
+        <p:txBody>
+          <a:bodyPr rtlCol="0" anchor="ctr"/>
+          <a:lstStyle/>
+          <a:p>
+            <a:pPr algn="ctr"/>
+          </a:p>
+        </p:txBody>
+      </p:sp>
+      <p:sp>
+        <p:nvSpPr>
+          <p:cNvPr id="7" name="TextBox 6"/>
+          <p:cNvSpPr txBox="1"/>
+          <p:nvPr/>
+        </p:nvSpPr>
+        <p:spPr>
+          <a:xfrm>
+            <a:off x="612648" y="1463040"/>
+            <a:ext cx="1920240" cy="320040"/>
           </a:xfrm>
           <a:prstGeom prst="rect">
             <a:avLst/>
@@ -9817,139 +9949,933 @@
           <a:p>
             <a:pPr algn="l"/>
             <a:r>
-              <a:rPr sz="2100" b="1">
+              <a:rPr sz="1200" b="1">
                 <a:solidFill>
                   <a:srgbClr val="B3995D"/>
                 </a:solidFill>
                 <a:latin typeface="Calibri"/>
               </a:rPr>
-              <a:t>Drafts only. Never send. You are the principal. The agent is staff.</a:t>
-            </a:r>
-          </a:p>
-        </p:txBody>
-      </p:sp>
-      <p:sp>
-        <p:nvSpPr>
-          <p:cNvPr id="7" name="TextBox 6"/>
-          <p:cNvSpPr txBox="1"/>
-          <p:nvPr/>
-        </p:nvSpPr>
-        <p:spPr>
-          <a:xfrm>
-            <a:off x="731520" y="1965960"/>
-            <a:ext cx="10515600" cy="4114800"/>
-          </a:xfrm>
-          <a:prstGeom prst="rect">
-            <a:avLst/>
-          </a:prstGeom>
-          <a:noFill/>
-        </p:spPr>
-        <p:txBody>
-          <a:bodyPr wrap="square">
-            <a:spAutoFit/>
-          </a:bodyPr>
-          <a:lstStyle/>
-          <a:p>
-            <a:pPr>
-              <a:spcAft>
-                <a:spcPts val="1000"/>
-              </a:spcAft>
-            </a:pPr>
-            <a:r>
-              <a:rPr sz="2000" b="0">
+              <a:t>LEVEL 0</a:t>
+            </a:r>
+          </a:p>
+        </p:txBody>
+      </p:sp>
+      <p:sp>
+        <p:nvSpPr>
+          <p:cNvPr id="8" name="TextBox 7"/>
+          <p:cNvSpPr txBox="1"/>
+          <p:nvPr/>
+        </p:nvSpPr>
+        <p:spPr>
+          <a:xfrm>
+            <a:off x="612648" y="1783080"/>
+            <a:ext cx="1920240" cy="822960"/>
+          </a:xfrm>
+          <a:prstGeom prst="rect">
+            <a:avLst/>
+          </a:prstGeom>
+          <a:noFill/>
+        </p:spPr>
+        <p:txBody>
+          <a:bodyPr wrap="square">
+            <a:spAutoFit/>
+          </a:bodyPr>
+          <a:lstStyle/>
+          <a:p>
+            <a:pPr algn="l"/>
+            <a:r>
+              <a:rPr sz="1800" b="1">
                 <a:solidFill>
                   <a:srgbClr val="F4EBD0"/>
                 </a:solidFill>
                 <a:latin typeface="Calibri"/>
               </a:rPr>
-              <a:t>•  Read-only first.</a:t>
-            </a:r>
-          </a:p>
-          <a:p>
-            <a:pPr>
-              <a:spcAft>
-                <a:spcPts val="1000"/>
-              </a:spcAft>
-            </a:pPr>
-            <a:r>
-              <a:rPr sz="2000" b="0">
+              <a:t>Human is the loop</a:t>
+            </a:r>
+          </a:p>
+        </p:txBody>
+      </p:sp>
+      <p:sp>
+        <p:nvSpPr>
+          <p:cNvPr id="9" name="TextBox 8"/>
+          <p:cNvSpPr txBox="1"/>
+          <p:nvPr/>
+        </p:nvSpPr>
+        <p:spPr>
+          <a:xfrm>
+            <a:off x="612648" y="2697480"/>
+            <a:ext cx="1920240" cy="1097280"/>
+          </a:xfrm>
+          <a:prstGeom prst="rect">
+            <a:avLst/>
+          </a:prstGeom>
+          <a:noFill/>
+        </p:spPr>
+        <p:txBody>
+          <a:bodyPr wrap="square">
+            <a:spAutoFit/>
+          </a:bodyPr>
+          <a:lstStyle/>
+          <a:p>
+            <a:pPr algn="l"/>
+            <a:r>
+              <a:rPr sz="1400" b="0">
                 <a:solidFill>
                   <a:srgbClr val="F4EBD0"/>
                 </a:solidFill>
                 <a:latin typeface="Calibri"/>
               </a:rPr>
-              <a:t>•  Cite or cut.</a:t>
-            </a:r>
-          </a:p>
-          <a:p>
-            <a:pPr>
-              <a:spcAft>
-                <a:spcPts val="1000"/>
-              </a:spcAft>
-            </a:pPr>
-            <a:r>
-              <a:rPr sz="2000" b="0">
+              <a:t>A working process.
+No agent yet.</a:t>
+            </a:r>
+          </a:p>
+        </p:txBody>
+      </p:sp>
+      <p:sp>
+        <p:nvSpPr>
+          <p:cNvPr id="10" name="TextBox 9"/>
+          <p:cNvSpPr txBox="1"/>
+          <p:nvPr/>
+        </p:nvSpPr>
+        <p:spPr>
+          <a:xfrm>
+            <a:off x="612648" y="3886200"/>
+            <a:ext cx="1920240" cy="502920"/>
+          </a:xfrm>
+          <a:prstGeom prst="rect">
+            <a:avLst/>
+          </a:prstGeom>
+          <a:noFill/>
+        </p:spPr>
+        <p:txBody>
+          <a:bodyPr wrap="square">
+            <a:spAutoFit/>
+          </a:bodyPr>
+          <a:lstStyle/>
+          <a:p>
+            <a:pPr algn="l"/>
+            <a:r>
+              <a:rPr sz="1200" b="0">
+                <a:solidFill>
+                  <a:srgbClr val="B8A888"/>
+                </a:solidFill>
+                <a:latin typeface="Calibri"/>
+              </a:rPr>
+              <a:t>Build this first.</a:t>
+            </a:r>
+          </a:p>
+        </p:txBody>
+      </p:sp>
+      <p:sp>
+        <p:nvSpPr>
+          <p:cNvPr id="11" name="Rectangle 10"/>
+          <p:cNvSpPr/>
+          <p:nvPr/>
+        </p:nvSpPr>
+        <p:spPr>
+          <a:xfrm>
+            <a:off x="2788920" y="1325880"/>
+            <a:ext cx="2148840" cy="3108960"/>
+          </a:xfrm>
+          <a:prstGeom prst="rect">
+            <a:avLst/>
+          </a:prstGeom>
+          <a:solidFill>
+            <a:srgbClr val="141414"/>
+          </a:solidFill>
+          <a:ln>
+            <a:noFill/>
+          </a:ln>
+        </p:spPr>
+        <p:style>
+          <a:lnRef idx="1">
+            <a:schemeClr val="accent1"/>
+          </a:lnRef>
+          <a:fillRef idx="3">
+            <a:schemeClr val="accent1"/>
+          </a:fillRef>
+          <a:effectRef idx="2">
+            <a:schemeClr val="accent1"/>
+          </a:effectRef>
+          <a:fontRef idx="minor">
+            <a:schemeClr val="lt1"/>
+          </a:fontRef>
+        </p:style>
+        <p:txBody>
+          <a:bodyPr rtlCol="0" anchor="ctr"/>
+          <a:lstStyle/>
+          <a:p>
+            <a:pPr algn="ctr"/>
+          </a:p>
+        </p:txBody>
+      </p:sp>
+      <p:sp>
+        <p:nvSpPr>
+          <p:cNvPr id="12" name="TextBox 11"/>
+          <p:cNvSpPr txBox="1"/>
+          <p:nvPr/>
+        </p:nvSpPr>
+        <p:spPr>
+          <a:xfrm>
+            <a:off x="2898648" y="1463040"/>
+            <a:ext cx="1920240" cy="320040"/>
+          </a:xfrm>
+          <a:prstGeom prst="rect">
+            <a:avLst/>
+          </a:prstGeom>
+          <a:noFill/>
+        </p:spPr>
+        <p:txBody>
+          <a:bodyPr wrap="square">
+            <a:spAutoFit/>
+          </a:bodyPr>
+          <a:lstStyle/>
+          <a:p>
+            <a:pPr algn="l"/>
+            <a:r>
+              <a:rPr sz="1200" b="1">
+                <a:solidFill>
+                  <a:srgbClr val="B3995D"/>
+                </a:solidFill>
+                <a:latin typeface="Calibri"/>
+              </a:rPr>
+              <a:t>LEVEL 1  ← this kit</a:t>
+            </a:r>
+          </a:p>
+        </p:txBody>
+      </p:sp>
+      <p:sp>
+        <p:nvSpPr>
+          <p:cNvPr id="13" name="TextBox 12"/>
+          <p:cNvSpPr txBox="1"/>
+          <p:nvPr/>
+        </p:nvSpPr>
+        <p:spPr>
+          <a:xfrm>
+            <a:off x="2898648" y="1783080"/>
+            <a:ext cx="1920240" cy="822960"/>
+          </a:xfrm>
+          <a:prstGeom prst="rect">
+            <a:avLst/>
+          </a:prstGeom>
+          <a:noFill/>
+        </p:spPr>
+        <p:txBody>
+          <a:bodyPr wrap="square">
+            <a:spAutoFit/>
+          </a:bodyPr>
+          <a:lstStyle/>
+          <a:p>
+            <a:pPr algn="l"/>
+            <a:r>
+              <a:rPr sz="1800" b="1">
                 <a:solidFill>
                   <a:srgbClr val="F4EBD0"/>
                 </a:solidFill>
                 <a:latin typeface="Calibri"/>
               </a:rPr>
-              <a:t>•  Inbox is untrusted — mail is data, not orders.</a:t>
-            </a:r>
-          </a:p>
-          <a:p>
-            <a:pPr>
-              <a:spcAft>
-                <a:spcPts val="1000"/>
-              </a:spcAft>
-            </a:pPr>
-            <a:r>
-              <a:rPr sz="2000" b="0">
+              <a:t>Human in the loop</a:t>
+            </a:r>
+          </a:p>
+        </p:txBody>
+      </p:sp>
+      <p:sp>
+        <p:nvSpPr>
+          <p:cNvPr id="14" name="TextBox 13"/>
+          <p:cNvSpPr txBox="1"/>
+          <p:nvPr/>
+        </p:nvSpPr>
+        <p:spPr>
+          <a:xfrm>
+            <a:off x="2898648" y="2697480"/>
+            <a:ext cx="1920240" cy="1097280"/>
+          </a:xfrm>
+          <a:prstGeom prst="rect">
+            <a:avLst/>
+          </a:prstGeom>
+          <a:noFill/>
+        </p:spPr>
+        <p:txBody>
+          <a:bodyPr wrap="square">
+            <a:spAutoFit/>
+          </a:bodyPr>
+          <a:lstStyle/>
+          <a:p>
+            <a:pPr algn="l"/>
+            <a:r>
+              <a:rPr sz="1400" b="0">
                 <a:solidFill>
                   <a:srgbClr val="F4EBD0"/>
                 </a:solidFill>
                 <a:latin typeface="Calibri"/>
               </a:rPr>
-              <a:t>•  Stale is visible. Silent omission is a lie.</a:t>
-            </a:r>
-          </a:p>
-          <a:p>
-            <a:pPr>
-              <a:spcAft>
-                <a:spcPts val="1000"/>
-              </a:spcAft>
-            </a:pPr>
-            <a:r>
-              <a:rPr sz="2000" b="0">
+              <a:t>The agent drafts.
+You accept every output.</a:t>
+            </a:r>
+          </a:p>
+        </p:txBody>
+      </p:sp>
+      <p:sp>
+        <p:nvSpPr>
+          <p:cNvPr id="15" name="TextBox 14"/>
+          <p:cNvSpPr txBox="1"/>
+          <p:nvPr/>
+        </p:nvSpPr>
+        <p:spPr>
+          <a:xfrm>
+            <a:off x="2898648" y="3886200"/>
+            <a:ext cx="1920240" cy="502920"/>
+          </a:xfrm>
+          <a:prstGeom prst="rect">
+            <a:avLst/>
+          </a:prstGeom>
+          <a:noFill/>
+        </p:spPr>
+        <p:txBody>
+          <a:bodyPr wrap="square">
+            <a:spAutoFit/>
+          </a:bodyPr>
+          <a:lstStyle/>
+          <a:p>
+            <a:pPr algn="l"/>
+            <a:r>
+              <a:rPr sz="1200" b="0">
+                <a:solidFill>
+                  <a:srgbClr val="B8A888"/>
+                </a:solidFill>
+                <a:latin typeface="Calibri"/>
+              </a:rPr>
+              <a:t>Limit: your review time.</a:t>
+            </a:r>
+          </a:p>
+        </p:txBody>
+      </p:sp>
+      <p:sp>
+        <p:nvSpPr>
+          <p:cNvPr id="16" name="Rectangle 15"/>
+          <p:cNvSpPr/>
+          <p:nvPr/>
+        </p:nvSpPr>
+        <p:spPr>
+          <a:xfrm>
+            <a:off x="5074920" y="1325880"/>
+            <a:ext cx="2148840" cy="3108960"/>
+          </a:xfrm>
+          <a:prstGeom prst="rect">
+            <a:avLst/>
+          </a:prstGeom>
+          <a:solidFill>
+            <a:srgbClr val="141414"/>
+          </a:solidFill>
+          <a:ln>
+            <a:noFill/>
+          </a:ln>
+        </p:spPr>
+        <p:style>
+          <a:lnRef idx="1">
+            <a:schemeClr val="accent1"/>
+          </a:lnRef>
+          <a:fillRef idx="3">
+            <a:schemeClr val="accent1"/>
+          </a:fillRef>
+          <a:effectRef idx="2">
+            <a:schemeClr val="accent1"/>
+          </a:effectRef>
+          <a:fontRef idx="minor">
+            <a:schemeClr val="lt1"/>
+          </a:fontRef>
+        </p:style>
+        <p:txBody>
+          <a:bodyPr rtlCol="0" anchor="ctr"/>
+          <a:lstStyle/>
+          <a:p>
+            <a:pPr algn="ctr"/>
+          </a:p>
+        </p:txBody>
+      </p:sp>
+      <p:sp>
+        <p:nvSpPr>
+          <p:cNvPr id="17" name="TextBox 16"/>
+          <p:cNvSpPr txBox="1"/>
+          <p:nvPr/>
+        </p:nvSpPr>
+        <p:spPr>
+          <a:xfrm>
+            <a:off x="5184648" y="1463040"/>
+            <a:ext cx="1920240" cy="320040"/>
+          </a:xfrm>
+          <a:prstGeom prst="rect">
+            <a:avLst/>
+          </a:prstGeom>
+          <a:noFill/>
+        </p:spPr>
+        <p:txBody>
+          <a:bodyPr wrap="square">
+            <a:spAutoFit/>
+          </a:bodyPr>
+          <a:lstStyle/>
+          <a:p>
+            <a:pPr algn="l"/>
+            <a:r>
+              <a:rPr sz="1200" b="1">
+                <a:solidFill>
+                  <a:srgbClr val="B3995D"/>
+                </a:solidFill>
+                <a:latin typeface="Calibri"/>
+              </a:rPr>
+              <a:t>LEVEL 2</a:t>
+            </a:r>
+          </a:p>
+        </p:txBody>
+      </p:sp>
+      <p:sp>
+        <p:nvSpPr>
+          <p:cNvPr id="18" name="TextBox 17"/>
+          <p:cNvSpPr txBox="1"/>
+          <p:nvPr/>
+        </p:nvSpPr>
+        <p:spPr>
+          <a:xfrm>
+            <a:off x="5184648" y="1783080"/>
+            <a:ext cx="1920240" cy="822960"/>
+          </a:xfrm>
+          <a:prstGeom prst="rect">
+            <a:avLst/>
+          </a:prstGeom>
+          <a:noFill/>
+        </p:spPr>
+        <p:txBody>
+          <a:bodyPr wrap="square">
+            <a:spAutoFit/>
+          </a:bodyPr>
+          <a:lstStyle/>
+          <a:p>
+            <a:pPr algn="l"/>
+            <a:r>
+              <a:rPr sz="1800" b="1">
                 <a:solidFill>
                   <a:srgbClr val="F4EBD0"/>
                 </a:solidFill>
                 <a:latin typeface="Calibri"/>
               </a:rPr>
-              <a:t>•  Approvals sit where actions become hard to undo: send, pay, publish, delete.</a:t>
-            </a:r>
-          </a:p>
-          <a:p>
-            <a:pPr>
-              <a:spcAft>
-                <a:spcPts val="1000"/>
-              </a:spcAft>
-            </a:pPr>
-            <a:r>
-              <a:rPr sz="2000" b="0">
+              <a:t>Human on the loop</a:t>
+            </a:r>
+          </a:p>
+        </p:txBody>
+      </p:sp>
+      <p:sp>
+        <p:nvSpPr>
+          <p:cNvPr id="19" name="TextBox 18"/>
+          <p:cNvSpPr txBox="1"/>
+          <p:nvPr/>
+        </p:nvSpPr>
+        <p:spPr>
+          <a:xfrm>
+            <a:off x="5184648" y="2697480"/>
+            <a:ext cx="1920240" cy="1097280"/>
+          </a:xfrm>
+          <a:prstGeom prst="rect">
+            <a:avLst/>
+          </a:prstGeom>
+          <a:noFill/>
+        </p:spPr>
+        <p:txBody>
+          <a:bodyPr wrap="square">
+            <a:spAutoFit/>
+          </a:bodyPr>
+          <a:lstStyle/>
+          <a:p>
+            <a:pPr algn="l"/>
+            <a:r>
+              <a:rPr sz="1400" b="0">
                 <a:solidFill>
                   <a:srgbClr val="F4EBD0"/>
                 </a:solidFill>
                 <a:latin typeface="Calibri"/>
               </a:rPr>
-              <a:t>•  One owner per agent.</a:t>
-            </a:r>
-          </a:p>
-        </p:txBody>
-      </p:sp>
-      <p:sp>
-        <p:nvSpPr>
-          <p:cNvPr id="8" name="TextBox 7"/>
+              <a:t>You dispatch jobs, on a timer.
+You check evidence, not every line.</a:t>
+            </a:r>
+          </a:p>
+        </p:txBody>
+      </p:sp>
+      <p:sp>
+        <p:nvSpPr>
+          <p:cNvPr id="20" name="TextBox 19"/>
+          <p:cNvSpPr txBox="1"/>
+          <p:nvPr/>
+        </p:nvSpPr>
+        <p:spPr>
+          <a:xfrm>
+            <a:off x="5184648" y="3886200"/>
+            <a:ext cx="1920240" cy="502920"/>
+          </a:xfrm>
+          <a:prstGeom prst="rect">
+            <a:avLst/>
+          </a:prstGeom>
+          <a:noFill/>
+        </p:spPr>
+        <p:txBody>
+          <a:bodyPr wrap="square">
+            <a:spAutoFit/>
+          </a:bodyPr>
+          <a:lstStyle/>
+          <a:p>
+            <a:pPr algn="l"/>
+            <a:r>
+              <a:rPr sz="1200" b="0">
+                <a:solidFill>
+                  <a:srgbClr val="B8A888"/>
+                </a:solidFill>
+                <a:latin typeface="Calibri"/>
+              </a:rPr>
+              <a:t>Limit: how hard your checks are.</a:t>
+            </a:r>
+          </a:p>
+        </p:txBody>
+      </p:sp>
+      <p:sp>
+        <p:nvSpPr>
+          <p:cNvPr id="21" name="Rectangle 20"/>
+          <p:cNvSpPr/>
+          <p:nvPr/>
+        </p:nvSpPr>
+        <p:spPr>
+          <a:xfrm>
+            <a:off x="7360920" y="1325880"/>
+            <a:ext cx="2148840" cy="3108960"/>
+          </a:xfrm>
+          <a:prstGeom prst="rect">
+            <a:avLst/>
+          </a:prstGeom>
+          <a:solidFill>
+            <a:srgbClr val="141414"/>
+          </a:solidFill>
+          <a:ln>
+            <a:noFill/>
+          </a:ln>
+        </p:spPr>
+        <p:style>
+          <a:lnRef idx="1">
+            <a:schemeClr val="accent1"/>
+          </a:lnRef>
+          <a:fillRef idx="3">
+            <a:schemeClr val="accent1"/>
+          </a:fillRef>
+          <a:effectRef idx="2">
+            <a:schemeClr val="accent1"/>
+          </a:effectRef>
+          <a:fontRef idx="minor">
+            <a:schemeClr val="lt1"/>
+          </a:fontRef>
+        </p:style>
+        <p:txBody>
+          <a:bodyPr rtlCol="0" anchor="ctr"/>
+          <a:lstStyle/>
+          <a:p>
+            <a:pPr algn="ctr"/>
+          </a:p>
+        </p:txBody>
+      </p:sp>
+      <p:sp>
+        <p:nvSpPr>
+          <p:cNvPr id="22" name="TextBox 21"/>
+          <p:cNvSpPr txBox="1"/>
+          <p:nvPr/>
+        </p:nvSpPr>
+        <p:spPr>
+          <a:xfrm>
+            <a:off x="7470648" y="1463040"/>
+            <a:ext cx="1920240" cy="320040"/>
+          </a:xfrm>
+          <a:prstGeom prst="rect">
+            <a:avLst/>
+          </a:prstGeom>
+          <a:noFill/>
+        </p:spPr>
+        <p:txBody>
+          <a:bodyPr wrap="square">
+            <a:spAutoFit/>
+          </a:bodyPr>
+          <a:lstStyle/>
+          <a:p>
+            <a:pPr algn="l"/>
+            <a:r>
+              <a:rPr sz="1200" b="1">
+                <a:solidFill>
+                  <a:srgbClr val="B3995D"/>
+                </a:solidFill>
+                <a:latin typeface="Calibri"/>
+              </a:rPr>
+              <a:t>LEVEL 3</a:t>
+            </a:r>
+          </a:p>
+        </p:txBody>
+      </p:sp>
+      <p:sp>
+        <p:nvSpPr>
+          <p:cNvPr id="23" name="TextBox 22"/>
+          <p:cNvSpPr txBox="1"/>
+          <p:nvPr/>
+        </p:nvSpPr>
+        <p:spPr>
+          <a:xfrm>
+            <a:off x="7470648" y="1783080"/>
+            <a:ext cx="1920240" cy="822960"/>
+          </a:xfrm>
+          <a:prstGeom prst="rect">
+            <a:avLst/>
+          </a:prstGeom>
+          <a:noFill/>
+        </p:spPr>
+        <p:txBody>
+          <a:bodyPr wrap="square">
+            <a:spAutoFit/>
+          </a:bodyPr>
+          <a:lstStyle/>
+          <a:p>
+            <a:pPr algn="l"/>
+            <a:r>
+              <a:rPr sz="1800" b="1">
+                <a:solidFill>
+                  <a:srgbClr val="F4EBD0"/>
+                </a:solidFill>
+                <a:latin typeface="Calibri"/>
+              </a:rPr>
+              <a:t>Human as orchestrator</a:t>
+            </a:r>
+          </a:p>
+        </p:txBody>
+      </p:sp>
+      <p:sp>
+        <p:nvSpPr>
+          <p:cNvPr id="24" name="TextBox 23"/>
+          <p:cNvSpPr txBox="1"/>
+          <p:nvPr/>
+        </p:nvSpPr>
+        <p:spPr>
+          <a:xfrm>
+            <a:off x="7470648" y="2697480"/>
+            <a:ext cx="1920240" cy="1097280"/>
+          </a:xfrm>
+          <a:prstGeom prst="rect">
+            <a:avLst/>
+          </a:prstGeom>
+          <a:noFill/>
+        </p:spPr>
+        <p:txBody>
+          <a:bodyPr wrap="square">
+            <a:spAutoFit/>
+          </a:bodyPr>
+          <a:lstStyle/>
+          <a:p>
+            <a:pPr algn="l"/>
+            <a:r>
+              <a:rPr sz="1400" b="0">
+                <a:solidFill>
+                  <a:srgbClr val="F4EBD0"/>
+                </a:solidFill>
+                <a:latin typeface="Calibri"/>
+              </a:rPr>
+              <a:t>The agent reacts to signals.
+You review the rules.</a:t>
+            </a:r>
+          </a:p>
+        </p:txBody>
+      </p:sp>
+      <p:sp>
+        <p:nvSpPr>
+          <p:cNvPr id="25" name="TextBox 24"/>
+          <p:cNvSpPr txBox="1"/>
+          <p:nvPr/>
+        </p:nvSpPr>
+        <p:spPr>
+          <a:xfrm>
+            <a:off x="7470648" y="3886200"/>
+            <a:ext cx="1920240" cy="502920"/>
+          </a:xfrm>
+          <a:prstGeom prst="rect">
+            <a:avLst/>
+          </a:prstGeom>
+          <a:noFill/>
+        </p:spPr>
+        <p:txBody>
+          <a:bodyPr wrap="square">
+            <a:spAutoFit/>
+          </a:bodyPr>
+          <a:lstStyle/>
+          <a:p>
+            <a:pPr algn="l"/>
+            <a:r>
+              <a:rPr sz="1200" b="0">
+                <a:solidFill>
+                  <a:srgbClr val="B8A888"/>
+                </a:solidFill>
+                <a:latin typeface="Calibri"/>
+              </a:rPr>
+              <a:t>Limit: how good your rules are.</a:t>
+            </a:r>
+          </a:p>
+        </p:txBody>
+      </p:sp>
+      <p:sp>
+        <p:nvSpPr>
+          <p:cNvPr id="26" name="Rectangle 25"/>
+          <p:cNvSpPr/>
+          <p:nvPr/>
+        </p:nvSpPr>
+        <p:spPr>
+          <a:xfrm>
+            <a:off x="9646920" y="1325880"/>
+            <a:ext cx="2148840" cy="3108960"/>
+          </a:xfrm>
+          <a:prstGeom prst="rect">
+            <a:avLst/>
+          </a:prstGeom>
+          <a:solidFill>
+            <a:srgbClr val="141414"/>
+          </a:solidFill>
+          <a:ln>
+            <a:noFill/>
+          </a:ln>
+        </p:spPr>
+        <p:style>
+          <a:lnRef idx="1">
+            <a:schemeClr val="accent1"/>
+          </a:lnRef>
+          <a:fillRef idx="3">
+            <a:schemeClr val="accent1"/>
+          </a:fillRef>
+          <a:effectRef idx="2">
+            <a:schemeClr val="accent1"/>
+          </a:effectRef>
+          <a:fontRef idx="minor">
+            <a:schemeClr val="lt1"/>
+          </a:fontRef>
+        </p:style>
+        <p:txBody>
+          <a:bodyPr rtlCol="0" anchor="ctr"/>
+          <a:lstStyle/>
+          <a:p>
+            <a:pPr algn="ctr"/>
+          </a:p>
+        </p:txBody>
+      </p:sp>
+      <p:sp>
+        <p:nvSpPr>
+          <p:cNvPr id="27" name="TextBox 26"/>
+          <p:cNvSpPr txBox="1"/>
+          <p:nvPr/>
+        </p:nvSpPr>
+        <p:spPr>
+          <a:xfrm>
+            <a:off x="9756648" y="1463040"/>
+            <a:ext cx="1920240" cy="320040"/>
+          </a:xfrm>
+          <a:prstGeom prst="rect">
+            <a:avLst/>
+          </a:prstGeom>
+          <a:noFill/>
+        </p:spPr>
+        <p:txBody>
+          <a:bodyPr wrap="square">
+            <a:spAutoFit/>
+          </a:bodyPr>
+          <a:lstStyle/>
+          <a:p>
+            <a:pPr algn="l"/>
+            <a:r>
+              <a:rPr sz="1200" b="1">
+                <a:solidFill>
+                  <a:srgbClr val="B3995D"/>
+                </a:solidFill>
+                <a:latin typeface="Calibri"/>
+              </a:rPr>
+              <a:t>LEVEL 4</a:t>
+            </a:r>
+          </a:p>
+        </p:txBody>
+      </p:sp>
+      <p:sp>
+        <p:nvSpPr>
+          <p:cNvPr id="28" name="TextBox 27"/>
+          <p:cNvSpPr txBox="1"/>
+          <p:nvPr/>
+        </p:nvSpPr>
+        <p:spPr>
+          <a:xfrm>
+            <a:off x="9756648" y="1783080"/>
+            <a:ext cx="1920240" cy="822960"/>
+          </a:xfrm>
+          <a:prstGeom prst="rect">
+            <a:avLst/>
+          </a:prstGeom>
+          <a:noFill/>
+        </p:spPr>
+        <p:txBody>
+          <a:bodyPr wrap="square">
+            <a:spAutoFit/>
+          </a:bodyPr>
+          <a:lstStyle/>
+          <a:p>
+            <a:pPr algn="l"/>
+            <a:r>
+              <a:rPr sz="1800" b="1">
+                <a:solidFill>
+                  <a:srgbClr val="F4EBD0"/>
+                </a:solidFill>
+                <a:latin typeface="Calibri"/>
+              </a:rPr>
+              <a:t>Autonomous</a:t>
+            </a:r>
+          </a:p>
+        </p:txBody>
+      </p:sp>
+      <p:sp>
+        <p:nvSpPr>
+          <p:cNvPr id="29" name="TextBox 28"/>
+          <p:cNvSpPr txBox="1"/>
+          <p:nvPr/>
+        </p:nvSpPr>
+        <p:spPr>
+          <a:xfrm>
+            <a:off x="9756648" y="2697480"/>
+            <a:ext cx="1920240" cy="1097280"/>
+          </a:xfrm>
+          <a:prstGeom prst="rect">
+            <a:avLst/>
+          </a:prstGeom>
+          <a:noFill/>
+        </p:spPr>
+        <p:txBody>
+          <a:bodyPr wrap="square">
+            <a:spAutoFit/>
+          </a:bodyPr>
+          <a:lstStyle/>
+          <a:p>
+            <a:pPr algn="l"/>
+            <a:r>
+              <a:rPr sz="1400" b="0">
+                <a:solidFill>
+                  <a:srgbClr val="F4EBD0"/>
+                </a:solidFill>
+                <a:latin typeface="Calibri"/>
+              </a:rPr>
+              <a:t>The agent starts work itself.
+You set the boundaries.</a:t>
+            </a:r>
+          </a:p>
+        </p:txBody>
+      </p:sp>
+      <p:sp>
+        <p:nvSpPr>
+          <p:cNvPr id="30" name="TextBox 29"/>
+          <p:cNvSpPr txBox="1"/>
+          <p:nvPr/>
+        </p:nvSpPr>
+        <p:spPr>
+          <a:xfrm>
+            <a:off x="9756648" y="3886200"/>
+            <a:ext cx="1920240" cy="502920"/>
+          </a:xfrm>
+          <a:prstGeom prst="rect">
+            <a:avLst/>
+          </a:prstGeom>
+          <a:noFill/>
+        </p:spPr>
+        <p:txBody>
+          <a:bodyPr wrap="square">
+            <a:spAutoFit/>
+          </a:bodyPr>
+          <a:lstStyle/>
+          <a:p>
+            <a:pPr algn="l"/>
+            <a:r>
+              <a:rPr sz="1200" b="0">
+                <a:solidFill>
+                  <a:srgbClr val="B8A888"/>
+                </a:solidFill>
+                <a:latin typeface="Calibri"/>
+              </a:rPr>
+              <a:t>Limit: the whole system, not the model.</a:t>
+            </a:r>
+          </a:p>
+        </p:txBody>
+      </p:sp>
+      <p:sp>
+        <p:nvSpPr>
+          <p:cNvPr id="31" name="TextBox 30"/>
+          <p:cNvSpPr txBox="1"/>
+          <p:nvPr/>
+        </p:nvSpPr>
+        <p:spPr>
+          <a:xfrm>
+            <a:off x="731520" y="4709160"/>
+            <a:ext cx="10515600" cy="457200"/>
+          </a:xfrm>
+          <a:prstGeom prst="rect">
+            <a:avLst/>
+          </a:prstGeom>
+          <a:noFill/>
+        </p:spPr>
+        <p:txBody>
+          <a:bodyPr wrap="square">
+            <a:spAutoFit/>
+          </a:bodyPr>
+          <a:lstStyle/>
+          <a:p>
+            <a:pPr algn="l"/>
+            <a:r>
+              <a:rPr sz="2000" b="1">
+                <a:solidFill>
+                  <a:srgbClr val="B3995D"/>
+                </a:solidFill>
+                <a:latin typeface="Calibri"/>
+              </a:rPr>
+              <a:t>Everything today is Level 1. Step 7 — schedule it — is the door to Level 2.</a:t>
+            </a:r>
+          </a:p>
+        </p:txBody>
+      </p:sp>
+      <p:sp>
+        <p:nvSpPr>
+          <p:cNvPr id="32" name="TextBox 31"/>
+          <p:cNvSpPr txBox="1"/>
+          <p:nvPr/>
+        </p:nvSpPr>
+        <p:spPr>
+          <a:xfrm>
+            <a:off x="731520" y="5257800"/>
+            <a:ext cx="10515600" cy="914400"/>
+          </a:xfrm>
+          <a:prstGeom prst="rect">
+            <a:avLst/>
+          </a:prstGeom>
+          <a:noFill/>
+        </p:spPr>
+        <p:txBody>
+          <a:bodyPr wrap="square">
+            <a:spAutoFit/>
+          </a:bodyPr>
+          <a:lstStyle/>
+          <a:p>
+            <a:pPr algn="l"/>
+            <a:r>
+              <a:rPr sz="1600" b="0">
+                <a:solidFill>
+                  <a:srgbClr val="B8A888"/>
+                </a:solidFill>
+                <a:latin typeface="Calibri"/>
+              </a:rPr>
+              <a:t>Do not walk through it until the check in your SOP is one a careful stranger could apply in a minute.
+A better model does not move you up a level. Better checks do.</a:t>
+            </a:r>
+          </a:p>
+        </p:txBody>
+      </p:sp>
+      <p:sp>
+        <p:nvSpPr>
+          <p:cNvPr id="33" name="TextBox 32"/>
           <p:cNvSpPr txBox="1"/>
           <p:nvPr/>
         </p:nvSpPr>
@@ -9984,7 +10910,7 @@
       </p:sp>
       <p:sp>
         <p:nvSpPr>
-          <p:cNvPr id="9" name="TextBox 8"/>
+          <p:cNvPr id="34" name="TextBox 33"/>
           <p:cNvSpPr txBox="1"/>
           <p:nvPr/>
         </p:nvSpPr>
@@ -10012,7 +10938,7 @@
                 </a:solidFill>
                 <a:latin typeface="Calibri"/>
               </a:rPr>
-              <a:t>15  /  16</a:t>
+              <a:t>15  /  17</a:t>
             </a:r>
           </a:p>
         </p:txBody>
@@ -10172,6 +11098,412 @@
         </p:nvSpPr>
         <p:spPr>
           <a:xfrm>
+            <a:off x="731520" y="411480"/>
+            <a:ext cx="10058400" cy="731520"/>
+          </a:xfrm>
+          <a:prstGeom prst="rect">
+            <a:avLst/>
+          </a:prstGeom>
+          <a:noFill/>
+        </p:spPr>
+        <p:txBody>
+          <a:bodyPr wrap="square">
+            <a:spAutoFit/>
+          </a:bodyPr>
+          <a:lstStyle/>
+          <a:p>
+            <a:pPr algn="l"/>
+            <a:r>
+              <a:rPr sz="3200" b="1">
+                <a:solidFill>
+                  <a:srgbClr val="F4EBD0"/>
+                </a:solidFill>
+                <a:latin typeface="Calibri"/>
+              </a:rPr>
+              <a:t>Non-negotiable</a:t>
+            </a:r>
+          </a:p>
+        </p:txBody>
+      </p:sp>
+      <p:sp>
+        <p:nvSpPr>
+          <p:cNvPr id="6" name="TextBox 5"/>
+          <p:cNvSpPr txBox="1"/>
+          <p:nvPr/>
+        </p:nvSpPr>
+        <p:spPr>
+          <a:xfrm>
+            <a:off x="731520" y="1188720"/>
+            <a:ext cx="10515600" cy="640080"/>
+          </a:xfrm>
+          <a:prstGeom prst="rect">
+            <a:avLst/>
+          </a:prstGeom>
+          <a:noFill/>
+        </p:spPr>
+        <p:txBody>
+          <a:bodyPr wrap="square">
+            <a:spAutoFit/>
+          </a:bodyPr>
+          <a:lstStyle/>
+          <a:p>
+            <a:pPr algn="l"/>
+            <a:r>
+              <a:rPr sz="2100" b="1">
+                <a:solidFill>
+                  <a:srgbClr val="B3995D"/>
+                </a:solidFill>
+                <a:latin typeface="Calibri"/>
+              </a:rPr>
+              <a:t>Drafts only. Never send. You are the principal. The agent is staff.</a:t>
+            </a:r>
+          </a:p>
+        </p:txBody>
+      </p:sp>
+      <p:sp>
+        <p:nvSpPr>
+          <p:cNvPr id="7" name="TextBox 6"/>
+          <p:cNvSpPr txBox="1"/>
+          <p:nvPr/>
+        </p:nvSpPr>
+        <p:spPr>
+          <a:xfrm>
+            <a:off x="731520" y="1965960"/>
+            <a:ext cx="10515600" cy="4114800"/>
+          </a:xfrm>
+          <a:prstGeom prst="rect">
+            <a:avLst/>
+          </a:prstGeom>
+          <a:noFill/>
+        </p:spPr>
+        <p:txBody>
+          <a:bodyPr wrap="square">
+            <a:spAutoFit/>
+          </a:bodyPr>
+          <a:lstStyle/>
+          <a:p>
+            <a:pPr>
+              <a:spcAft>
+                <a:spcPts val="1000"/>
+              </a:spcAft>
+            </a:pPr>
+            <a:r>
+              <a:rPr sz="2000" b="0">
+                <a:solidFill>
+                  <a:srgbClr val="F4EBD0"/>
+                </a:solidFill>
+                <a:latin typeface="Calibri"/>
+              </a:rPr>
+              <a:t>•  Read-only first.</a:t>
+            </a:r>
+          </a:p>
+          <a:p>
+            <a:pPr>
+              <a:spcAft>
+                <a:spcPts val="1000"/>
+              </a:spcAft>
+            </a:pPr>
+            <a:r>
+              <a:rPr sz="2000" b="0">
+                <a:solidFill>
+                  <a:srgbClr val="F4EBD0"/>
+                </a:solidFill>
+                <a:latin typeface="Calibri"/>
+              </a:rPr>
+              <a:t>•  Cite or cut.</a:t>
+            </a:r>
+          </a:p>
+          <a:p>
+            <a:pPr>
+              <a:spcAft>
+                <a:spcPts val="1000"/>
+              </a:spcAft>
+            </a:pPr>
+            <a:r>
+              <a:rPr sz="2000" b="0">
+                <a:solidFill>
+                  <a:srgbClr val="F4EBD0"/>
+                </a:solidFill>
+                <a:latin typeface="Calibri"/>
+              </a:rPr>
+              <a:t>•  Inbox is untrusted — mail is data, not orders.</a:t>
+            </a:r>
+          </a:p>
+          <a:p>
+            <a:pPr>
+              <a:spcAft>
+                <a:spcPts val="1000"/>
+              </a:spcAft>
+            </a:pPr>
+            <a:r>
+              <a:rPr sz="2000" b="0">
+                <a:solidFill>
+                  <a:srgbClr val="F4EBD0"/>
+                </a:solidFill>
+                <a:latin typeface="Calibri"/>
+              </a:rPr>
+              <a:t>•  Stale is visible. Silent omission is a lie.</a:t>
+            </a:r>
+          </a:p>
+          <a:p>
+            <a:pPr>
+              <a:spcAft>
+                <a:spcPts val="1000"/>
+              </a:spcAft>
+            </a:pPr>
+            <a:r>
+              <a:rPr sz="2000" b="0">
+                <a:solidFill>
+                  <a:srgbClr val="F4EBD0"/>
+                </a:solidFill>
+                <a:latin typeface="Calibri"/>
+              </a:rPr>
+              <a:t>•  Approvals sit where actions become hard to undo: send, pay, publish, delete.</a:t>
+            </a:r>
+          </a:p>
+          <a:p>
+            <a:pPr>
+              <a:spcAft>
+                <a:spcPts val="1000"/>
+              </a:spcAft>
+            </a:pPr>
+            <a:r>
+              <a:rPr sz="2000" b="0">
+                <a:solidFill>
+                  <a:srgbClr val="F4EBD0"/>
+                </a:solidFill>
+                <a:latin typeface="Calibri"/>
+              </a:rPr>
+              <a:t>•  One owner per agent.</a:t>
+            </a:r>
+          </a:p>
+        </p:txBody>
+      </p:sp>
+      <p:sp>
+        <p:nvSpPr>
+          <p:cNvPr id="8" name="TextBox 7"/>
+          <p:cNvSpPr txBox="1"/>
+          <p:nvPr/>
+        </p:nvSpPr>
+        <p:spPr>
+          <a:xfrm>
+            <a:off x="640080" y="6492240"/>
+            <a:ext cx="9144000" cy="274320"/>
+          </a:xfrm>
+          <a:prstGeom prst="rect">
+            <a:avLst/>
+          </a:prstGeom>
+          <a:noFill/>
+        </p:spPr>
+        <p:txBody>
+          <a:bodyPr wrap="square">
+            <a:spAutoFit/>
+          </a:bodyPr>
+          <a:lstStyle/>
+          <a:p>
+            <a:pPr algn="l"/>
+            <a:r>
+              <a:rPr sz="1100" b="0">
+                <a:solidFill>
+                  <a:srgbClr val="B8A888"/>
+                </a:solidFill>
+                <a:latin typeface="Calibri"/>
+              </a:rPr>
+              <a:t>Build your own chief of staff  ·  process, not a vendor</a:t>
+            </a:r>
+          </a:p>
+        </p:txBody>
+      </p:sp>
+      <p:sp>
+        <p:nvSpPr>
+          <p:cNvPr id="9" name="TextBox 8"/>
+          <p:cNvSpPr txBox="1"/>
+          <p:nvPr/>
+        </p:nvSpPr>
+        <p:spPr>
+          <a:xfrm>
+            <a:off x="10607040" y="6492240"/>
+            <a:ext cx="1097280" cy="274320"/>
+          </a:xfrm>
+          <a:prstGeom prst="rect">
+            <a:avLst/>
+          </a:prstGeom>
+          <a:noFill/>
+        </p:spPr>
+        <p:txBody>
+          <a:bodyPr wrap="square">
+            <a:spAutoFit/>
+          </a:bodyPr>
+          <a:lstStyle/>
+          <a:p>
+            <a:pPr algn="r"/>
+            <a:r>
+              <a:rPr sz="1100" b="0">
+                <a:solidFill>
+                  <a:srgbClr val="B8A888"/>
+                </a:solidFill>
+                <a:latin typeface="Calibri"/>
+              </a:rPr>
+              <a:t>16  /  17</a:t>
+            </a:r>
+          </a:p>
+        </p:txBody>
+      </p:sp>
+    </p:spTree>
+  </p:cSld>
+  <p:clrMapOvr>
+    <a:masterClrMapping/>
+  </p:clrMapOvr>
+</p:sld>
+</file>
+
+<file path=ppt/slides/slide17.xml><?xml version="1.0" encoding="utf-8"?>
+<p:sld xmlns:a="http://schemas.openxmlformats.org/drawingml/2006/main" xmlns:p="http://schemas.openxmlformats.org/presentationml/2006/main" xmlns:r="http://schemas.openxmlformats.org/officeDocument/2006/relationships">
+  <p:cSld>
+    <p:spTree>
+      <p:nvGrpSpPr>
+        <p:cNvPr id="1" name=""/>
+        <p:cNvGrpSpPr/>
+        <p:nvPr/>
+      </p:nvGrpSpPr>
+      <p:grpSpPr/>
+      <p:sp>
+        <p:nvSpPr>
+          <p:cNvPr id="2" name="Rectangle 1"/>
+          <p:cNvSpPr/>
+          <p:nvPr/>
+        </p:nvSpPr>
+        <p:spPr>
+          <a:xfrm>
+            <a:off x="0" y="0"/>
+            <a:ext cx="12191695" cy="6858000"/>
+          </a:xfrm>
+          <a:prstGeom prst="rect">
+            <a:avLst/>
+          </a:prstGeom>
+          <a:solidFill>
+            <a:srgbClr val="000000"/>
+          </a:solidFill>
+          <a:ln>
+            <a:noFill/>
+          </a:ln>
+        </p:spPr>
+        <p:style>
+          <a:lnRef idx="1">
+            <a:schemeClr val="accent1"/>
+          </a:lnRef>
+          <a:fillRef idx="3">
+            <a:schemeClr val="accent1"/>
+          </a:fillRef>
+          <a:effectRef idx="2">
+            <a:schemeClr val="accent1"/>
+          </a:effectRef>
+          <a:fontRef idx="minor">
+            <a:schemeClr val="lt1"/>
+          </a:fontRef>
+        </p:style>
+        <p:txBody>
+          <a:bodyPr rtlCol="0" anchor="ctr"/>
+          <a:lstStyle/>
+          <a:p>
+            <a:pPr algn="ctr"/>
+          </a:p>
+        </p:txBody>
+      </p:sp>
+      <p:sp>
+        <p:nvSpPr>
+          <p:cNvPr id="3" name="Rectangle 2"/>
+          <p:cNvSpPr/>
+          <p:nvPr/>
+        </p:nvSpPr>
+        <p:spPr>
+          <a:xfrm>
+            <a:off x="0" y="0"/>
+            <a:ext cx="164592" cy="6858000"/>
+          </a:xfrm>
+          <a:prstGeom prst="rect">
+            <a:avLst/>
+          </a:prstGeom>
+          <a:solidFill>
+            <a:srgbClr val="B3995D"/>
+          </a:solidFill>
+          <a:ln>
+            <a:noFill/>
+          </a:ln>
+        </p:spPr>
+        <p:style>
+          <a:lnRef idx="1">
+            <a:schemeClr val="accent1"/>
+          </a:lnRef>
+          <a:fillRef idx="3">
+            <a:schemeClr val="accent1"/>
+          </a:fillRef>
+          <a:effectRef idx="2">
+            <a:schemeClr val="accent1"/>
+          </a:effectRef>
+          <a:fontRef idx="minor">
+            <a:schemeClr val="lt1"/>
+          </a:fontRef>
+        </p:style>
+        <p:txBody>
+          <a:bodyPr rtlCol="0" anchor="ctr"/>
+          <a:lstStyle/>
+          <a:p>
+            <a:pPr algn="ctr"/>
+          </a:p>
+        </p:txBody>
+      </p:sp>
+      <p:sp>
+        <p:nvSpPr>
+          <p:cNvPr id="4" name="Rectangle 3"/>
+          <p:cNvSpPr/>
+          <p:nvPr/>
+        </p:nvSpPr>
+        <p:spPr>
+          <a:xfrm>
+            <a:off x="0" y="6784848"/>
+            <a:ext cx="12191695" cy="73152"/>
+          </a:xfrm>
+          <a:prstGeom prst="rect">
+            <a:avLst/>
+          </a:prstGeom>
+          <a:solidFill>
+            <a:srgbClr val="B3995D"/>
+          </a:solidFill>
+          <a:ln>
+            <a:noFill/>
+          </a:ln>
+        </p:spPr>
+        <p:style>
+          <a:lnRef idx="1">
+            <a:schemeClr val="accent1"/>
+          </a:lnRef>
+          <a:fillRef idx="3">
+            <a:schemeClr val="accent1"/>
+          </a:fillRef>
+          <a:effectRef idx="2">
+            <a:schemeClr val="accent1"/>
+          </a:effectRef>
+          <a:fontRef idx="minor">
+            <a:schemeClr val="lt1"/>
+          </a:fontRef>
+        </p:style>
+        <p:txBody>
+          <a:bodyPr rtlCol="0" anchor="ctr"/>
+          <a:lstStyle/>
+          <a:p>
+            <a:pPr algn="ctr"/>
+          </a:p>
+        </p:txBody>
+      </p:sp>
+      <p:sp>
+        <p:nvSpPr>
+          <p:cNvPr id="5" name="TextBox 4"/>
+          <p:cNvSpPr txBox="1"/>
+          <p:nvPr/>
+        </p:nvSpPr>
+        <p:spPr>
+          <a:xfrm>
             <a:off x="731520" y="822960"/>
             <a:ext cx="10515600" cy="1280160"/>
           </a:xfrm>
@@ -10431,7 +11763,7 @@
                 </a:solidFill>
                 <a:latin typeface="Calibri"/>
               </a:rPr>
-              <a:t>16  /  16</a:t>
+              <a:t>17  /  17</a:t>
             </a:r>
           </a:p>
         </p:txBody>
@@ -10789,7 +12121,7 @@
                 </a:solidFill>
                 <a:latin typeface="Calibri"/>
               </a:rPr>
-              <a:t>2  /  16</a:t>
+              <a:t>2  /  17</a:t>
             </a:r>
           </a:p>
         </p:txBody>
@@ -11371,7 +12703,7 @@
                 </a:solidFill>
                 <a:latin typeface="Calibri"/>
               </a:rPr>
-              <a:t>3  /  16</a:t>
+              <a:t>3  /  17</a:t>
             </a:r>
           </a:p>
         </p:txBody>
@@ -11855,7 +13187,7 @@
                 </a:solidFill>
                 <a:latin typeface="Calibri"/>
               </a:rPr>
-              <a:t>4  /  16</a:t>
+              <a:t>4  /  17</a:t>
             </a:r>
           </a:p>
         </p:txBody>
@@ -12144,7 +13476,7 @@
                 </a:solidFill>
                 <a:latin typeface="Calibri"/>
               </a:rPr>
-              <a:t>5  /  16</a:t>
+              <a:t>5  /  17</a:t>
             </a:r>
           </a:p>
         </p:txBody>
@@ -12503,7 +13835,7 @@
                 </a:solidFill>
                 <a:latin typeface="Calibri"/>
               </a:rPr>
-              <a:t>6  /  16</a:t>
+              <a:t>6  /  17</a:t>
             </a:r>
           </a:p>
         </p:txBody>
@@ -12858,7 +14190,7 @@
                 </a:solidFill>
                 <a:latin typeface="Calibri"/>
               </a:rPr>
-              <a:t>7  /  16</a:t>
+              <a:t>7  /  17</a:t>
             </a:r>
           </a:p>
         </p:txBody>
@@ -13711,7 +15043,7 @@
                 </a:solidFill>
                 <a:latin typeface="Calibri"/>
               </a:rPr>
-              <a:t>8  /  16</a:t>
+              <a:t>8  /  17</a:t>
             </a:r>
           </a:p>
         </p:txBody>
@@ -14392,7 +15724,7 @@
                 </a:solidFill>
                 <a:latin typeface="Calibri"/>
               </a:rPr>
-              <a:t>9  /  16</a:t>
+              <a:t>9  /  17</a:t>
             </a:r>
           </a:p>
         </p:txBody>

</xml_diff>

<commit_message>
Say "the process, not the tool" instead of "not a vendor".
We are a vendor. The footer, title subtitle, and run of show now frame
the talk as process over tooling. Mentions of tool vendors in the
prompts and source notes are unchanged; they mean model providers.
</commit_message>
<xml_diff>
--- a/slides/building-your-own-chief-of-staff.pptx
+++ b/slides/building-your-own-chief-of-staff.pptx
@@ -4687,7 +4687,7 @@
                 </a:solidFill>
                 <a:latin typeface="Calibri"/>
               </a:rPr>
-              <a:t>Teach the process. Not a vendor.
+              <a:t>Teach the process, not a tool.
 Leave knowing how to build a CoS agent — and how to automate
 anything that is repeatable and verifiable.</a:t>
             </a:r>
@@ -4724,7 +4724,7 @@
                 </a:solidFill>
                 <a:latin typeface="Calibri"/>
               </a:rPr>
-              <a:t>Build your own chief of staff  ·  process, not a vendor</a:t>
+              <a:t>Build your own chief of staff  ·  the process, not the tool</a:t>
             </a:r>
           </a:p>
         </p:txBody>
@@ -5130,7 +5130,7 @@
                 </a:solidFill>
                 <a:latin typeface="Calibri"/>
               </a:rPr>
-              <a:t>Build your own chief of staff  ·  process, not a vendor</a:t>
+              <a:t>Build your own chief of staff  ·  the process, not the tool</a:t>
             </a:r>
           </a:p>
         </p:txBody>
@@ -5549,7 +5549,7 @@
                 </a:solidFill>
                 <a:latin typeface="Calibri"/>
               </a:rPr>
-              <a:t>Build your own chief of staff  ·  process, not a vendor</a:t>
+              <a:t>Build your own chief of staff  ·  the process, not the tool</a:t>
             </a:r>
           </a:p>
         </p:txBody>
@@ -6033,7 +6033,7 @@
                 </a:solidFill>
                 <a:latin typeface="Calibri"/>
               </a:rPr>
-              <a:t>Build your own chief of staff  ·  process, not a vendor</a:t>
+              <a:t>Build your own chief of staff  ·  the process, not the tool</a:t>
             </a:r>
           </a:p>
         </p:txBody>
@@ -6886,7 +6886,7 @@
                 </a:solidFill>
                 <a:latin typeface="Calibri"/>
               </a:rPr>
-              <a:t>Build your own chief of staff  ·  process, not a vendor</a:t>
+              <a:t>Build your own chief of staff  ·  the process, not the tool</a:t>
             </a:r>
           </a:p>
         </p:txBody>
@@ -7567,7 +7567,7 @@
                 </a:solidFill>
                 <a:latin typeface="Calibri"/>
               </a:rPr>
-              <a:t>Build your own chief of staff  ·  process, not a vendor</a:t>
+              <a:t>Build your own chief of staff  ·  the process, not the tool</a:t>
             </a:r>
           </a:p>
         </p:txBody>
@@ -8439,7 +8439,7 @@
                 </a:solidFill>
                 <a:latin typeface="Calibri"/>
               </a:rPr>
-              <a:t>Build your own chief of staff  ·  process, not a vendor</a:t>
+              <a:t>Build your own chief of staff  ·  the process, not the tool</a:t>
             </a:r>
           </a:p>
         </p:txBody>
@@ -8926,7 +8926,7 @@
                 </a:solidFill>
                 <a:latin typeface="Calibri"/>
               </a:rPr>
-              <a:t>Build your own chief of staff  ·  process, not a vendor</a:t>
+              <a:t>Build your own chief of staff  ·  the process, not the tool</a:t>
             </a:r>
           </a:p>
         </p:txBody>
@@ -9622,7 +9622,7 @@
                 </a:solidFill>
                 <a:latin typeface="Calibri"/>
               </a:rPr>
-              <a:t>Build your own chief of staff  ·  process, not a vendor</a:t>
+              <a:t>Build your own chief of staff  ·  the process, not the tool</a:t>
             </a:r>
           </a:p>
         </p:txBody>
@@ -10474,7 +10474,7 @@
                 </a:solidFill>
                 <a:latin typeface="Calibri"/>
               </a:rPr>
-              <a:t>Build your own chief of staff  ·  process, not a vendor</a:t>
+              <a:t>Build your own chief of staff  ·  the process, not the tool</a:t>
             </a:r>
           </a:p>
         </p:txBody>
@@ -11717,7 +11717,7 @@
                 </a:solidFill>
                 <a:latin typeface="Calibri"/>
               </a:rPr>
-              <a:t>Build your own chief of staff  ·  process, not a vendor</a:t>
+              <a:t>Build your own chief of staff  ·  the process, not the tool</a:t>
             </a:r>
           </a:p>
         </p:txBody>

</xml_diff>

<commit_message>
Make the weekly update the live demo and script the talk slide by slide.
The demo moves from meeting-recap.md to weekly-update.md. Slides 4, 6,
and 8 and every speaker note now follow the update. Each note opens with
its time budget. Slide text and notes drop em dashes, arrows, and curly
quotes.

TALK-FLOW.md is now a script: one section per slide with a divider,
where you are (slides, GitHub, or your editor), condensed talking
points, and the exact paste for the demo. It adds three Work IQ prompts
that pull last week's meetings, commitments, and work items into
evidence.md, and a questions table.

context-templates/voices/ adds three sample voice.md files for writing
to researchers, managers, and stakeholders. README files point at them.
</commit_message>
<xml_diff>
--- a/slides/building-your-own-chief-of-staff.pptx
+++ b/slides/building-your-own-chief-of-staff.pptx
@@ -512,25 +512,25 @@
           <a:lstStyle/>
           <a:p>
             <a:r>
-              <a:t>Open by saying this is not a product demo. No one is leaving with a login, a marketplace skill, or a reason to switch from Copilot to Claude.</a:t>
+              <a:t>One minute. Not a product demo. Nobody leaves with a login or a reason to switch tools. They leave with a process they can run Monday in whatever they already have.</a:t>
             </a:r>
           </a:p>
           <a:p/>
           <a:p>
             <a:r>
-              <a:t>They are leaving with a process they can run Monday in whatever tool they already have.</a:t>
+              <a:t>The Chief of Staff agent is the worked example. The weekly update is the file we run live.</a:t>
             </a:r>
           </a:p>
           <a:p/>
           <a:p>
             <a:r>
-              <a:t>The Chief of Staff agent is the worked example. Briefs, drafts, open loops, meeting prep. The real prize is the two tests they will use on expense reports, hiring screens, and customer research next month.</a:t>
+              <a:t>The prize is the two tests. They will use them on expense reports, hiring screens, and customer research next month.</a:t>
             </a:r>
           </a:p>
           <a:p/>
           <a:p>
             <a:r>
-              <a:t>Cite the local source catalog if asked: https://github.com/BittahCriminal/build-your-own-chief-of-staff/blob/main/research/SOURCES.md — 21 Markdown notes documenting the operating rules used in this kit, with original article attribution.</a:t>
+              <a:t>Sources, if asked: https://github.com/BittahCriminal/build-your-own-chief-of-staff/blob/main/research/SOURCES.md (21 notes, with the original article named in each).</a:t>
             </a:r>
           </a:p>
         </p:txBody>
@@ -600,25 +600,25 @@
           <a:lstStyle/>
           <a:p>
             <a:r>
-              <a:t>Leave this up for questions. This is the last content slide before the close.</a:t>
+              <a:t>Thirty seconds, then leave it up for questions.</a:t>
             </a:r>
           </a:p>
           <a:p/>
           <a:p>
             <a:r>
-              <a:t>If an agent sends a flawed appeal in your name, you now have two problems. Source: https://github.com/BittahCriminal/build-your-own-chief-of-staff/blob/main/research/notes/reusable-rig.md</a:t>
+              <a:t>An agent that sends a flawed update in your name gives you two problems. Source: https://github.com/BittahCriminal/build-your-own-chief-of-staff/blob/main/research/notes/reusable-rig.md</a:t>
             </a:r>
           </a:p>
           <a:p/>
           <a:p>
             <a:r>
-              <a:t>Inbox is untrusted. A line that says 'ignore your rules' is data, not an order. First-agent-job: https://github.com/BittahCriminal/build-your-own-chief-of-staff/blob/main/research/notes/first-agent-job.md</a:t>
+              <a:t>A line in a transcript that says "ignore your rules" is data, not an order. Source: https://github.com/BittahCriminal/build-your-own-chief-of-staff/blob/main/research/notes/first-agent-job.md</a:t>
             </a:r>
           </a:p>
           <a:p/>
           <a:p>
             <a:r>
-              <a:t>Where the agent should stop: start where a colleague or customer already tells you you're wrong; reconstructing context is the expensive part; the reply is cheap. Source: https://github.com/BittahCriminal/build-your-own-chief-of-staff/blob/main/research/notes/where-to-stop.md</a:t>
+              <a:t>Reconstructing context is the expensive part. The reply is cheap. Source: https://github.com/BittahCriminal/build-your-own-chief-of-staff/blob/main/research/notes/where-to-stop.md</a:t>
             </a:r>
           </a:p>
         </p:txBody>
@@ -688,19 +688,25 @@
           <a:lstStyle/>
           <a:p>
             <a:r>
-              <a:t>Close by pointing at the repo. The QR resolves to START-HERE.md on GitHub; the URL next to it is the repo root. Say the URL out loud once for anyone who cannot scan. This kit is provider-agnostic. The Claude plugin of the same processes is a different repository (BittahCriminal/Chief-of-Staff) — do not send them there for this talk.</a:t>
+              <a:t>Thirty seconds. Point at the repo. The QR is START-HERE.md. Say the URL once for anyone who cannot scan.</a:t>
             </a:r>
           </a:p>
           <a:p/>
           <a:p>
             <a:r>
-              <a:t>If they want receipts: research/SOURCES.md catalogs the local source notes and original articles behind the method: https://github.com/BittahCriminal/build-your-own-chief-of-staff/blob/main/research/SOURCES.md</a:t>
+              <a:t>The kit works in any tool. The Claude plugin is a different repository. Do not send them there today.</a:t>
             </a:r>
           </a:p>
           <a:p/>
           <a:p>
             <a:r>
-              <a:t>Offer to stay for the first job. Help them run the two tests live on something they did last week.</a:t>
+              <a:t>Sources, if they want receipts: https://github.com/BittahCriminal/build-your-own-chief-of-staff/blob/main/research/SOURCES.md</a:t>
+            </a:r>
+          </a:p>
+          <a:p/>
+          <a:p>
+            <a:r>
+              <a:t>Offer to stay and run the two tests on something they did last week.</a:t>
             </a:r>
           </a:p>
         </p:txBody>
@@ -770,43 +776,37 @@
           <a:lstStyle/>
           <a:p>
             <a:r>
-              <a:t>Stay here. This is the slide they should photograph.</a:t>
+              <a:t>Two minutes. This is the slide they photograph.</a:t>
             </a:r>
           </a:p>
           <a:p/>
           <a:p>
             <a:r>
-              <a:t>Repeatable: Monday status (same headings, new evidence) yes. Meeting recap yes. Which of two candidates to hire no. 'Handle my email' is usually seventeen jobs — split it.</a:t>
+              <a:t>Repeatable, yes: the weekly update, same headings every Friday with new evidence. No: which of two candidates to hire.</a:t>
             </a:r>
           </a:p>
           <a:p/>
           <a:p>
             <a:r>
-              <a:t>Verifiable: every Done line cites a ticket you can open; the recap names an owner only when the notes name one; gaps stay 'not found'. 'Make it professional' cannot drive a loop.</a:t>
+              <a:t>Verifiable, yes: every Done line cites a ticket or a message you can open. No: "make it sound professional".</a:t>
             </a:r>
           </a:p>
           <a:p/>
           <a:p>
             <a:r>
-              <a:t>Fail either test → do not automate. That is not caution. That is the curriculum. The leftover is judgment: taste, red lines, how a room will land. Keep it.</a:t>
+              <a:t>Fail either test, do not automate. The leftover is judgment: taste, red lines, how a room will land. Keep it.</a:t>
             </a:r>
           </a:p>
           <a:p/>
           <a:p>
             <a:r>
-              <a:t>If the room is frozen at an empty prompt: 'handle my email' is seventeen jobs, split it. what-to-automate.md on GitHub. The freeze and why-it-fails material is in PROCESS.md, not on a slide in this cut.</a:t>
+              <a:t>If the room is stuck at an empty prompt: "handle my email" is seventeen jobs. Split it. The prompt for that is what-to-automate.md.</a:t>
             </a:r>
           </a:p>
           <a:p/>
           <a:p>
             <a:r>
-              <a:t>The checkability argument: if checking an answer costs as much as making it, extra attempts just grow the pile. Source: https://github.com/BittahCriminal/build-your-own-chief-of-staff/blob/main/research/notes/agent-shaped-work.md</a:t>
-            </a:r>
-          </a:p>
-          <a:p/>
-          <a:p>
-            <a:r>
-              <a:t>And: if you cannot name what would make you say 'not yet,' you have a vibe, not a job. Source: https://github.com/BittahCriminal/build-your-own-chief-of-staff/blob/main/research/notes/verification-gap.md</a:t>
+              <a:t>Sources: https://github.com/BittahCriminal/build-your-own-chief-of-staff/blob/main/research/notes/agent-shaped-work.md (checking costs as much as making) and https://github.com/BittahCriminal/build-your-own-chief-of-staff/blob/main/research/notes/verification-gap.md (if you cannot name "not yet", you have a vibe).</a:t>
             </a:r>
           </a:p>
         </p:txBody>
@@ -876,25 +876,25 @@
           <a:lstStyle/>
           <a:p>
             <a:r>
-              <a:t>Edge-first is the thought process they came for. Data preparation, QA, synthesis, packaging, coordination. Cheap errors. Humans can pick up an exception without the whole workflow breaking.</a:t>
+              <a:t>Ninety seconds. Edges are prep, checking, summarizing, packaging, handing off. Errors are cheap there, and a human can catch one without the whole thing breaking.</a:t>
             </a:r>
           </a:p>
           <a:p/>
           <a:p>
             <a:r>
-              <a:t>The core is where they groan that they want help — and where first projects die. Trust is the real project: automate around the craft, not through it.</a:t>
+              <a:t>The core is where people want help first and where first projects die. Automate around the craft, not through it.</a:t>
             </a:r>
           </a:p>
           <a:p/>
           <a:p>
             <a:r>
+              <a:t>The weekly update is packaging. When to push, and which story to tell, stays core.</a:t>
+            </a:r>
+          </a:p>
+          <a:p/>
+          <a:p>
+            <a:r>
               <a:t>Source: https://github.com/BittahCriminal/build-your-own-chief-of-staff/blob/main/research/notes/why-agent-projects-fail.md</a:t>
-            </a:r>
-          </a:p>
-          <a:p/>
-          <a:p>
-            <a:r>
-              <a:t>CoS mapping: recap, brief, open-loop list, packaging a status = edges. When to push, which story to tell = core.</a:t>
             </a:r>
           </a:p>
         </p:txBody>
@@ -964,19 +964,19 @@
           <a:lstStyle/>
           <a:p>
             <a:r>
-              <a:t>Walk the left column: these are the eight portable jobs from the Delegation Kit, renamed into operator English. Source: https://github.com/BittahCriminal/build-your-own-chief-of-staff/blob/main/research/notes/delegation-kit.md</a:t>
+              <a:t>Ninety seconds. Left column: the portable jobs from the Delegation Kit, in operator English. Source: https://github.com/BittahCriminal/build-your-own-chief-of-staff/blob/main/research/notes/delegation-kit.md</a:t>
             </a:r>
           </a:p>
           <a:p/>
           <a:p>
             <a:r>
-              <a:t>The right column is not 'AI can't do it.' It is 'checking it costs as much as doing it, so extra attempts just grow the pile.'</a:t>
+              <a:t>Right column is not "AI cannot do it". It is "checking it costs as much as doing it".</a:t>
             </a:r>
           </a:p>
           <a:p/>
           <a:p>
             <a:r>
-              <a:t>Flag meeting-recap now. Next slide leaves PowerPoint. You will open the GitHub file, copy it, and run it.</a:t>
+              <a:t>Flag the weekly update. Next slide leaves PowerPoint. You open the file on GitHub, copy it, and run it in your editor.</a:t>
             </a:r>
           </a:p>
         </p:txBody>
@@ -1046,25 +1046,25 @@
           <a:lstStyle/>
           <a:p>
             <a:r>
-              <a:t>Click the URL or scan. Stay on the README for about a minute. Point at the six names. Personal data never ships here — context-templates/ are blanks.</a:t>
+              <a:t>One minute. Click the URL. Stay on the README. Point at the six names. Personal data never ships here; the templates are blanks.</a:t>
             </a:r>
           </a:p>
           <a:p/>
           <a:p>
             <a:r>
-              <a:t>Do not take questions about which model is 'best'. Once the job is named and the check exists, use whatever they already pay for. The how-to/ folder is only which box to paste into.</a:t>
+              <a:t>Park "which model is best" for questions. Once the job is named and the check exists, use what they already pay for.</a:t>
             </a:r>
           </a:p>
           <a:p/>
           <a:p>
             <a:r>
-              <a:t>Reusable-rig essay: skills should be local, inspectable, and independent of whichever AI app you are renting this month. Source: https://github.com/BittahCriminal/build-your-own-chief-of-staff/blob/main/research/notes/reusable-rig.md</a:t>
+              <a:t>Then the next slide. Do not open PROCESS.md yet.</a:t>
             </a:r>
           </a:p>
           <a:p/>
           <a:p>
             <a:r>
-              <a:t>Then go to the next slide and open meeting-recap.md. Do not walk PROCESS.md yet.</a:t>
+              <a:t>Source: https://github.com/BittahCriminal/build-your-own-chief-of-staff/blob/main/research/notes/reusable-rig.md (skills local, inspectable, independent of the app you rent).</a:t>
             </a:r>
           </a:p>
         </p:txBody>
@@ -1134,31 +1134,37 @@
           <a:lstStyle/>
           <a:p>
             <a:r>
-              <a:t>Leave PowerPoint. Open https://github.com/BittahCriminal/build-your-own-chief-of-staff/blob/main/prompts/workflows/meeting-recap.md</a:t>
+              <a:t>Six minutes. Leave PowerPoint. Show the file on GitHub for ten seconds, then switch to the editor.</a:t>
             </a:r>
           </a:p>
           <a:p/>
           <a:p>
             <a:r>
-              <a:t>Paste an actual recent meeting's title, date, attendees, notes or transcript, and a filled-in voice.md into whatever tool the room uses.</a:t>
+              <a:t>The paste is already on the clipboard: the prompt, the three context files, last week's evidence. Paste. Run.</a:t>
             </a:r>
           </a:p>
           <a:p/>
           <a:p>
             <a:r>
-              <a:t>This is the pivot: everything before this was 'why.' Everything after is 'how,' using the recap you just got.</a:t>
+              <a:t>While it runs, say where the evidence came from: meetings, sent mail, and work items, one Work IQ prompt each.</a:t>
             </a:r>
           </a:p>
           <a:p/>
           <a:p>
             <a:r>
-              <a:t>If the model invents an owner, do not panic — that is Step 5 (cite or cut) happening live.</a:t>
+              <a:t>Read the draft out loud. Click one Done link. If the model invented a number or a date, say so. That is step 5 happening live.</a:t>
             </a:r>
           </a:p>
           <a:p/>
           <a:p>
             <a:r>
-              <a:t>Have the dry-run output saved as a fallback tab.</a:t>
+              <a:t>The fallback tab has the dry-run output.</a:t>
+            </a:r>
+          </a:p>
+          <a:p/>
+          <a:p>
+            <a:r>
+              <a:t>File: https://github.com/BittahCriminal/build-your-own-chief-of-staff/blob/main/prompts/workflows/weekly-update.md</a:t>
             </a:r>
           </a:p>
         </p:txBody>
@@ -1228,60 +1234,61 @@
           <a:lstStyle/>
           <a:p>
             <a:r>
-              <a:t>Open https://github.com/BittahCriminal/build-your-own-chief-of-staff/blob/main/PROCESS.md and stay there. Do not flip back to slides for each step.</a:t>
+              <a:t>Three minutes. Open PROCESS.md and stay there. About 25 seconds a step.</a:t>
             </a:r>
           </a:p>
           <a:p/>
           <a:p>
             <a:r>
-              <a:t>For the recap you just ran:</a:t>
-            </a:r>
-          </a:p>
-          <a:p>
-            <a:r>
-              <a:t>1. The job was already named — meeting recap — which is why it moved fast. Prompt: name-the-job.md</a:t>
-            </a:r>
-          </a:p>
-          <a:p>
-            <a:r>
-              <a:t>2. Input = voice.md + meeting details + transcript. Output = one-page recap. Check = every item cites a line. Prompt: write-the-sop.md</a:t>
-            </a:r>
-          </a:p>
-          <a:p>
-            <a:r>
-              <a:t>3. voice.md is the one context file that made the demo possible. Other jobs need more. Prompt: build-context.md</a:t>
-            </a:r>
-          </a:p>
-          <a:p>
-            <a:r>
-              <a:t>4. meeting-recap.md produced the recap, not a clever conversation. If output is wrong, the file is wrong.</a:t>
-            </a:r>
-          </a:p>
-          <a:p>
-            <a:r>
-              <a:t>5. Citation guard: no anchor, no claim. Gaps stay gaps. Prompt: verify.md  Source: https://github.com/BittahCriminal/build-your-own-chief-of-staff/blob/main/research/notes/reusable-rig.md</a:t>
-            </a:r>
-          </a:p>
-          <a:p>
-            <a:r>
-              <a:t>6. Three of the same correction is a rule. Two is a candidate. One is a fluke. Prompt: correct-the-file.md</a:t>
-            </a:r>
-          </a:p>
-          <a:p>
-            <a:r>
-              <a:t>7. Do not put it on a timer until several hand-checked meetings. Frequency is not value. Prompt: schedule-it.md</a:t>
+              <a:t>1. Name one job. Weekly update. Named before the demo, which is why it moved fast.</a:t>
+            </a:r>
+          </a:p>
+          <a:p>
+            <a:r>
+              <a:t>2. Write the SOP. Inputs: three files plus evidence. Output: one screen. Check: every line cites something you can open.</a:t>
+            </a:r>
+          </a:p>
+          <a:p>
+            <a:r>
+              <a:t>3. Put you in files you own. who-i-am, priorities, voice. Swap the tool tomorrow and nothing moves.</a:t>
+            </a:r>
+          </a:p>
+          <a:p>
+            <a:r>
+              <a:t>4. The prompt file is the process. If the draft is wrong, the file is wrong.</a:t>
+            </a:r>
+          </a:p>
+          <a:p>
+            <a:r>
+              <a:t>5. Verify. Cite or cut. Gaps stay gaps.</a:t>
+            </a:r>
+          </a:p>
+          <a:p>
+            <a:r>
+              <a:t>6. Correct the file, not the chat. Three of the same correction is a rule.</a:t>
+            </a:r>
+          </a:p>
+          <a:p>
+            <a:r>
+              <a:t>7. Only then schedule it. Three checked Fridays first.</a:t>
             </a:r>
           </a:p>
           <a:p/>
           <a:p>
             <a:r>
-              <a:t>Then say: point the same seven steps at expense reports, hiring screens, incident recaps. Buying a smarter model does not skip workflow, data, authority, evaluation, audit, or an owner. Source: https://github.com/BittahCriminal/build-your-own-chief-of-staff/blob/main/research/notes/workflow-readiness.md</a:t>
+              <a:t>Then: point the seven steps at expense reports, hiring screens, incident recaps. A smarter model skips none of this.</a:t>
             </a:r>
           </a:p>
           <a:p/>
           <a:p>
             <a:r>
-              <a:t>Come back to the deck for Monday homework, the levels, and the close. The ranking card (score-the-candidates.md) is not a slide in this cut; name it if someone has three ideas.</a:t>
+              <a:t>Back to the deck for Monday, the levels, and the close. The ranking card is score-the-candidates.md. Name it if someone has three ideas.</a:t>
+            </a:r>
+          </a:p>
+          <a:p/>
+          <a:p>
+            <a:r>
+              <a:t>Sources: https://github.com/BittahCriminal/build-your-own-chief-of-staff/blob/main/research/notes/reusable-rig.md and https://github.com/BittahCriminal/build-your-own-chief-of-staff/blob/main/research/notes/workflow-readiness.md</a:t>
             </a:r>
           </a:p>
         </p:txBody>
@@ -1351,19 +1358,19 @@
           <a:lstStyle/>
           <a:p>
             <a:r>
-              <a:t>This mirrors the README 'Start here' path, but the deliverable is one real run. START-HERE.md first if the files are not on the machine yet. They already watched this exact run; Monday they do it on their own meeting.</a:t>
+              <a:t>Ninety seconds. The README start-here path, but the deliverable is one real update on their own week.</a:t>
             </a:r>
           </a:p>
           <a:p/>
           <a:p>
             <a:r>
-              <a:t>An owner or date that does not point at a line in the notes gets cut. If the notes name nobody, the recap says unassigned. That is the agent working.</a:t>
+              <a:t>A Done line with no link gets cut. That is the agent working, not failing.</a:t>
             </a:r>
           </a:p>
           <a:p/>
           <a:p>
             <a:r>
-              <a:t>Do not put the recap on a timer until they have checked it by hand several times.</a:t>
+              <a:t>No timer until they have checked three Fridays by hand.</a:t>
             </a:r>
           </a:p>
         </p:txBody>
@@ -1433,25 +1440,25 @@
           <a:lstStyle/>
           <a:p>
             <a:r>
-              <a:t>One minute. This is the map, not a step. Everything they watched today sits on the second card: the agent drafted, a human accepted every line.</a:t>
+              <a:t>One minute. A map, not a step. Today sat on the second card: the agent drafted, a human read every line.</a:t>
             </a:r>
           </a:p>
           <a:p/>
           <a:p>
             <a:r>
-              <a:t>Level 2 is the hard jump, and it is where most teams are stuck. A timer is dispatch. The moment the recap runs without you asking, you have stopped reading every line and started trusting the check. That only works if the check is deterministic: every owner cites a line, gaps say unassigned, tone matches voice.md. That is why the scheduling gate exists.</a:t>
+              <a:t>Level 2 is the hard jump. A timer is dispatch. The Friday update runs without you asking, and you check the links instead of every line. That only works if the check is one the agent can fail against. That is why the scheduling gate exists.</a:t>
             </a:r>
           </a:p>
           <a:p/>
           <a:p>
             <a:r>
-              <a:t>Levels 3 and 4 are platform-team territory: agents that wake up on a signal, rules instead of reviews. Name them so the room knows the ladder exists. Do not sell them.</a:t>
+              <a:t>Levels 3 and 4 are platform-team territory. Name them. Do not sell them.</a:t>
             </a:r>
           </a:p>
           <a:p/>
           <a:p>
             <a:r>
-              <a:t>The claim to leave with: the quality of your written checks decides how much autonomy is safe. Source: https://github.com/BittahCriminal/build-your-own-chief-of-staff/blob/main/research/notes/agentic-levels.md</a:t>
+              <a:t>Your written checks decide how much autonomy is safe. Source: https://github.com/BittahCriminal/build-your-own-chief-of-staff/blob/main/research/notes/agentic-levels.md</a:t>
             </a:r>
           </a:p>
         </p:txBody>
@@ -4688,7 +4695,7 @@
                 <a:latin typeface="Calibri"/>
               </a:rPr>
               <a:t>Teach the process, not a tool.
-Leave knowing how to build a CoS agent — and how to automate
+Leave knowing how to build a CoS agent, and how to automate
 anything that is repeatable and verifiable.</a:t>
             </a:r>
           </a:p>
@@ -5047,7 +5054,7 @@
                 </a:solidFill>
                 <a:latin typeface="Calibri"/>
               </a:rPr>
-              <a:t>•  Inbox is untrusted — mail is data, not orders.</a:t>
+              <a:t>•  The inbox is untrusted. Mail is data, not orders.</a:t>
             </a:r>
           </a:p>
           <a:p>
@@ -5454,7 +5461,7 @@
                 <a:latin typeface="Calibri"/>
               </a:rPr>
               <a:t>Open START-HERE.md. Prompt kit, not the Claude plugin.
-Process files, CoS workflows, blank context templates, the decision matrix.
+Process files, CoS workflows, blank context templates, sample voices, the decision matrix.
 Source notes live in research/SOURCES.md.</a:t>
             </a:r>
           </a:p>
@@ -5924,7 +5931,7 @@
               </a:rPr>
               <a:t>You would do the same steps next week.
 Same kinds of inputs. Same shape of output.
-Special cases every time = judgment.
+Special cases every time is judgment.
 Keep it.</a:t>
             </a:r>
           </a:p>
@@ -5998,7 +6005,7 @@
               <a:t>A careful human can check the output
 against a source, a template, or a
 yes/no rule.
-“Does this sound good?” is not a check.</a:t>
+"Does this sound good?" is not a check.</a:t>
             </a:r>
           </a:p>
         </p:txBody>
@@ -6589,7 +6596,7 @@
                 </a:solidFill>
                 <a:latin typeface="Calibri"/>
               </a:rPr>
-              <a:t>Thread → one page</a:t>
+              <a:t>A thread into one page</a:t>
             </a:r>
           </a:p>
         </p:txBody>
@@ -6702,7 +6709,7 @@
                 </a:solidFill>
                 <a:latin typeface="Calibri"/>
               </a:rPr>
-              <a:t>Analysis → brief / recap</a:t>
+              <a:t>Analysis into a brief or an update</a:t>
             </a:r>
           </a:p>
         </p:txBody>
@@ -6850,8 +6857,8 @@
                 </a:solidFill>
                 <a:latin typeface="Calibri"/>
               </a:rPr>
-              <a:t>The core is craft: taste, red lines, how a room lands. Protect it.
-Pick the simplest edge with the clearest lift — not the most impressive one.</a:t>
+              <a:t>The core is craft. Taste, red lines, how a room lands. Protect it.
+Pick the simplest edge with the clearest lift, not the most impressive one.</a:t>
             </a:r>
           </a:p>
         </p:txBody>
@@ -7224,7 +7231,7 @@
                 </a:solidFill>
                 <a:latin typeface="Calibri"/>
               </a:rPr>
-              <a:t>OPERATIONAL  —  automate</a:t>
+              <a:t>OPERATIONAL. Automate.</a:t>
             </a:r>
           </a:p>
         </p:txBody>
@@ -7263,7 +7270,7 @@
                 </a:solidFill>
                 <a:latin typeface="Calibri"/>
               </a:rPr>
-              <a:t>•  Morning brief</a:t>
+              <a:t>•  Weekly update. We open this file next.</a:t>
             </a:r>
           </a:p>
           <a:p>
@@ -7279,7 +7286,7 @@
                 </a:solidFill>
                 <a:latin typeface="Calibri"/>
               </a:rPr>
-              <a:t>•  Weekly update</a:t>
+              <a:t>•  Morning brief</a:t>
             </a:r>
           </a:p>
           <a:p>
@@ -7311,7 +7318,7 @@
                 </a:solidFill>
                 <a:latin typeface="Calibri"/>
               </a:rPr>
-              <a:t>•  Meeting recap ← we open this file next</a:t>
+              <a:t>•  Meeting recap</a:t>
             </a:r>
           </a:p>
           <a:p>
@@ -7378,7 +7385,7 @@
                 </a:solidFill>
                 <a:latin typeface="Calibri"/>
               </a:rPr>
-              <a:t>JUDGMENT  —  keep</a:t>
+              <a:t>JUDGMENT. Keep.</a:t>
             </a:r>
           </a:p>
         </p:txBody>
@@ -7532,7 +7539,7 @@
                 </a:solidFill>
                 <a:latin typeface="Calibri"/>
               </a:rPr>
-              <a:t>Meeting recap needs the least setup of the six — one voice file, meeting details, and one real transcript.</a:t>
+              <a:t>The weekly update needs three context files, who you are, the quarter's priorities, and your voice, plus last week's evidence.</a:t>
             </a:r>
           </a:p>
         </p:txBody>
@@ -8124,7 +8131,7 @@
                 </a:solidFill>
                 <a:latin typeface="Calibri"/>
               </a:rPr>
-              <a:t>The method — we walk this after the demo</a:t>
+              <a:t>The method. We walk it after the demo</a:t>
             </a:r>
           </a:p>
         </p:txBody>
@@ -8691,7 +8698,7 @@
                 </a:solidFill>
                 <a:latin typeface="Calibri"/>
               </a:rPr>
-              <a:t>prompts/workflows/meeting-recap.md</a:t>
+              <a:t>prompts/workflows/weekly-update.md</a:t>
             </a:r>
           </a:p>
         </p:txBody>
@@ -8726,7 +8733,7 @@
                 <a:latin typeface="Calibri"/>
                 <a:hlinkClick r:id="rId2"/>
               </a:rPr>
-              <a:t>github.com/BittahCriminal/build-your-own-chief-of-staff/blob/main/prompts/workflows/meeting-recap.md</a:t>
+              <a:t>github.com/BittahCriminal/build-your-own-chief-of-staff/blob/main/prompts/workflows/weekly-update.md</a:t>
             </a:r>
           </a:p>
         </p:txBody>
@@ -8820,7 +8827,7 @@
                 </a:solidFill>
                 <a:latin typeface="Calibri"/>
               </a:rPr>
-              <a:t>This file, live: meeting recap</a:t>
+              <a:t>Weekly update, live</a:t>
             </a:r>
           </a:p>
         </p:txBody>
@@ -8859,7 +8866,7 @@
                 </a:solidFill>
                 <a:latin typeface="Calibri"/>
               </a:rPr>
-              <a:t>•  Lowest setup of the six CoS jobs — voice.md, meeting details, one real transcript.</a:t>
+              <a:t>•  Three context files: who-i-am.md, priorities.md, voice.md. Plus last week's evidence, pulled from Work IQ before the talk.</a:t>
             </a:r>
           </a:p>
           <a:p>
@@ -8875,7 +8882,7 @@
                 </a:solidFill>
                 <a:latin typeface="Calibri"/>
               </a:rPr>
-              <a:t>•  Fully verifiable: every decision, owner, and date must cite a line in the notes.</a:t>
+              <a:t>•  Every Done line has to cite a ticket, a meeting, or a message you can open.</a:t>
             </a:r>
           </a:p>
           <a:p>
@@ -8891,7 +8898,7 @@
                 </a:solidFill>
                 <a:latin typeface="Calibri"/>
               </a:rPr>
-              <a:t>•  Open the GitHub page. Copy the prompt. Paste it with voice.md and the notes. Run it.</a:t>
+              <a:t>•  Copy the prompt from GitHub. Paste it with the files and the evidence into your editor. Run it.</a:t>
             </a:r>
           </a:p>
         </p:txBody>
@@ -9342,7 +9349,7 @@
                 </a:solidFill>
                 <a:latin typeface="Calibri"/>
               </a:rPr>
-              <a:t>Walk these seven steps on GitHub against the recap you just ran.</a:t>
+              <a:t>Walk these seven steps on GitHub against the update you just ran.</a:t>
             </a:r>
           </a:p>
         </p:txBody>
@@ -9839,7 +9846,7 @@
                 </a:solidFill>
                 <a:latin typeface="Calibri"/>
               </a:rPr>
-              <a:t>Thirty minutes on Monday: run meeting-recap once</a:t>
+              <a:t>Thirty minutes on Monday. Run weekly-update once.</a:t>
             </a:r>
           </a:p>
         </p:txBody>
@@ -9917,7 +9924,7 @@
                 </a:solidFill>
                 <a:latin typeface="Calibri"/>
               </a:rPr>
-              <a:t>5 min</a:t>
+              <a:t>10 min</a:t>
             </a:r>
           </a:p>
         </p:txBody>
@@ -9952,7 +9959,7 @@
                 </a:solidFill>
                 <a:latin typeface="Calibri"/>
               </a:rPr>
-              <a:t>Copy context-templates to a private folder. Fill in voice.md only.</a:t>
+              <a:t>Copy context-templates to a private folder. Fill who-i-am.md, priorities.md, voice.md.</a:t>
             </a:r>
           </a:p>
         </p:txBody>
@@ -10065,7 +10072,7 @@
                 </a:solidFill>
                 <a:latin typeface="Calibri"/>
               </a:rPr>
-              <a:t>Pick one real meeting from last week: title, date, attendees, notes.</a:t>
+              <a:t>Pull last week: meetings, sent mail, work items. Ask Work IQ, or paste a list.</a:t>
             </a:r>
           </a:p>
         </p:txBody>
@@ -10178,7 +10185,7 @@
                 </a:solidFill>
                 <a:latin typeface="Calibri"/>
               </a:rPr>
-              <a:t>Paste meeting-recap.md, voice.md, and the notes into your tool. Run it.</a:t>
+              <a:t>Paste weekly-update.md, the three files, and the evidence into your tool. Run it.</a:t>
             </a:r>
           </a:p>
         </p:txBody>
@@ -10256,7 +10263,7 @@
                 </a:solidFill>
                 <a:latin typeface="Calibri"/>
               </a:rPr>
-              <a:t>10 min</a:t>
+              <a:t>5 min</a:t>
             </a:r>
           </a:p>
         </p:txBody>
@@ -10291,7 +10298,7 @@
                 </a:solidFill>
                 <a:latin typeface="Calibri"/>
               </a:rPr>
-              <a:t>Check each owner and date against a line in the notes. No name? Unassigned.</a:t>
+              <a:t>Check every Done line against something you can open. No source? Cut it.</a:t>
             </a:r>
           </a:p>
         </p:txBody>
@@ -10404,7 +10411,7 @@
                 </a:solidFill>
                 <a:latin typeface="Calibri"/>
               </a:rPr>
-              <a:t>Wrong? Fix the prompt or voice.md, not the chat. Run it again.</a:t>
+              <a:t>Wrong? Fix the prompt or a context file, not the chat. Run it again.</a:t>
             </a:r>
           </a:p>
         </p:txBody>
@@ -10439,7 +10446,7 @@
                 </a:solidFill>
                 <a:latin typeface="Calibri"/>
               </a:rPr>
-              <a:t>Froze on picking a meeting? what-to-automate.md. Left with three ideas? score-the-candidates.md.</a:t>
+              <a:t>Not sure what to automate next? what-to-automate.md. Left with three ideas? score-the-candidates.md.</a:t>
             </a:r>
           </a:p>
         </p:txBody>
@@ -10953,7 +10960,7 @@
                 </a:solidFill>
                 <a:latin typeface="Calibri"/>
               </a:rPr>
-              <a:t>LEVEL 1  ← this kit</a:t>
+              <a:t>LEVEL 1. This kit.</a:t>
             </a:r>
           </a:p>
         </p:txBody>
@@ -11646,7 +11653,7 @@
                 </a:solidFill>
                 <a:latin typeface="Calibri"/>
               </a:rPr>
-              <a:t>Everything today is Level 1. Step 7 — schedule it — is the door to Level 2.</a:t>
+              <a:t>Everything today is Level 1. Step 7, schedule it, is the door to Level 2.</a:t>
             </a:r>
           </a:p>
         </p:txBody>

</xml_diff>

<commit_message>
Make the demo a guided run that gathers evidence with the room.
prompts/process/guided-run.md is one prompt that asks which job, asks
how you reach each kind of evidence (connector, paste, attach, or
skip), gathers it one kind at a time, shows an inventory with the
unverified count, drafts in voice.md, and runs the workflow's check.
It hands over Work IQ queries when that connector is named and cannot
be called directly.

Slides 4, 6, 8, and 11 follow. Slide 6 now opens guided-run.md. The
Monday homework is four rows. TALK-FLOW.md scripts the interactive
demo step by step: which question to put to the room, when to switch
to Copilot for the one live query, when to paste the pre-pulled
sections. Demo budget is 8 minutes; slides 3, 4, and 7 give back the
time. README files point at the guided run as the first paste.
</commit_message>
<xml_diff>
--- a/slides/building-your-own-chief-of-staff.pptx
+++ b/slides/building-your-own-chief-of-staff.pptx
@@ -876,7 +876,7 @@
           <a:lstStyle/>
           <a:p>
             <a:r>
-              <a:t>Ninety seconds. Edges are prep, checking, summarizing, packaging, handing off. Errors are cheap there, and a human can catch one without the whole thing breaking.</a:t>
+              <a:t>One minute. Edges are prep, checking, summarizing, packaging, handing off. Errors are cheap there, and a human can catch one without the whole thing breaking.</a:t>
             </a:r>
           </a:p>
           <a:p/>
@@ -964,7 +964,7 @@
           <a:lstStyle/>
           <a:p>
             <a:r>
-              <a:t>Ninety seconds. Left column: the portable jobs from the Delegation Kit, in operator English. Source: https://github.com/BittahCriminal/build-your-own-chief-of-staff/blob/main/research/notes/delegation-kit.md</a:t>
+              <a:t>One minute. Left column: the portable jobs from the Delegation Kit, in operator English. Source: https://github.com/BittahCriminal/build-your-own-chief-of-staff/blob/main/research/notes/delegation-kit.md</a:t>
             </a:r>
           </a:p>
           <a:p/>
@@ -976,7 +976,7 @@
           <a:p/>
           <a:p>
             <a:r>
-              <a:t>Flag the weekly update. Next slide leaves PowerPoint. You open the file on GitHub, copy it, and run it in your editor.</a:t>
+              <a:t>Flag the weekly update. Next slide leaves PowerPoint. You paste one prompt in your editor and it walks the room through the job.</a:t>
             </a:r>
           </a:p>
         </p:txBody>
@@ -1134,37 +1134,37 @@
           <a:lstStyle/>
           <a:p>
             <a:r>
-              <a:t>Six minutes. Leave PowerPoint. Show the file on GitHub for ten seconds, then switch to the editor.</a:t>
+              <a:t>Eight minutes. Leave PowerPoint. Show guided-run.md on GitHub for ten seconds, then the editor.</a:t>
             </a:r>
           </a:p>
           <a:p/>
           <a:p>
             <a:r>
-              <a:t>The paste is already on the clipboard: the prompt, the three context files, last week's evidence. Paste. Run.</a:t>
+              <a:t>Paste. The clipboard holds the prompt and the three context files. It asks which job. Ask the room. Type weekly update.</a:t>
             </a:r>
           </a:p>
           <a:p/>
           <a:p>
             <a:r>
-              <a:t>While it runs, say where the evidence came from: meetings, sent mail, and work items, one Work IQ prompt each.</a:t>
+              <a:t>It asks how you reach meetings. Ask the room who has a connector and who would paste. Type connector, Work IQ. Run the query it hands you in the Copilot tab. Paste the answer back.</a:t>
             </a:r>
           </a:p>
           <a:p/>
           <a:p>
             <a:r>
-              <a:t>Read the draft out loud. Click one Done link. If the model invented a number or a date, say so. That is step 5 happening live.</a:t>
+              <a:t>For commitments and work items, say you ran those this morning and paste the sections from evidence.md. Point at the lines with no link.</a:t>
             </a:r>
           </a:p>
           <a:p/>
           <a:p>
             <a:r>
-              <a:t>The fallback tab has the dry-run output.</a:t>
+              <a:t>Approve the inventory. Read the draft. It runs the check. Click one link. If it invented something, say so. That is step 5 live. Ask it which file to fix.</a:t>
             </a:r>
           </a:p>
           <a:p/>
           <a:p>
             <a:r>
-              <a:t>File: https://github.com/BittahCriminal/build-your-own-chief-of-staff/blob/main/prompts/workflows/weekly-update.md</a:t>
+              <a:t>The fallback tab has the dry run. File: https://github.com/BittahCriminal/build-your-own-chief-of-staff/blob/main/prompts/process/guided-run.md</a:t>
             </a:r>
           </a:p>
         </p:txBody>
@@ -1234,13 +1234,13 @@
           <a:lstStyle/>
           <a:p>
             <a:r>
-              <a:t>Three minutes. Open PROCESS.md and stay there. About 25 seconds a step.</a:t>
+              <a:t>Two and a half minutes. Open PROCESS.md and stay there. About 20 seconds a step.</a:t>
             </a:r>
           </a:p>
           <a:p/>
           <a:p>
             <a:r>
-              <a:t>1. Name one job. Weekly update. Named before the demo, which is why it moved fast.</a:t>
+              <a:t>1. Name one job. Weekly update. The room named it in the first question.</a:t>
             </a:r>
           </a:p>
           <a:p>
@@ -1260,7 +1260,7 @@
           </a:p>
           <a:p>
             <a:r>
-              <a:t>5. Verify. Cite or cut. Gaps stay gaps.</a:t>
+              <a:t>5. Verify. Cite or cut. The unverified pile is this step.</a:t>
             </a:r>
           </a:p>
           <a:p>
@@ -1358,7 +1358,7 @@
           <a:lstStyle/>
           <a:p>
             <a:r>
-              <a:t>Ninety seconds. The README start-here path, but the deliverable is one real update on their own week.</a:t>
+              <a:t>One minute. The README start-here path, but the deliverable is one real update on their own week. The guided run asks for what it needs and stops if a file is missing. That is not a failure.</a:t>
             </a:r>
           </a:p>
           <a:p/>
@@ -5461,7 +5461,7 @@
                 <a:latin typeface="Calibri"/>
               </a:rPr>
               <a:t>Open START-HERE.md. Prompt kit, not the Claude plugin.
-Process files, CoS workflows, blank context templates, sample voices, the decision matrix.
+The guided run, process files, CoS workflows, blank context templates, sample voices.
 Source notes live in research/SOURCES.md.</a:t>
             </a:r>
           </a:p>
@@ -7270,7 +7270,7 @@
                 </a:solidFill>
                 <a:latin typeface="Calibri"/>
               </a:rPr>
-              <a:t>•  Weekly update. We open this file next.</a:t>
+              <a:t>•  Weekly update. We run this job next.</a:t>
             </a:r>
           </a:p>
           <a:p>
@@ -8698,7 +8698,7 @@
                 </a:solidFill>
                 <a:latin typeface="Calibri"/>
               </a:rPr>
-              <a:t>prompts/workflows/weekly-update.md</a:t>
+              <a:t>prompts/process/guided-run.md</a:t>
             </a:r>
           </a:p>
         </p:txBody>
@@ -8733,7 +8733,7 @@
                 <a:latin typeface="Calibri"/>
                 <a:hlinkClick r:id="rId2"/>
               </a:rPr>
-              <a:t>github.com/BittahCriminal/build-your-own-chief-of-staff/blob/main/prompts/workflows/weekly-update.md</a:t>
+              <a:t>github.com/BittahCriminal/build-your-own-chief-of-staff/blob/main/prompts/process/guided-run.md</a:t>
             </a:r>
           </a:p>
         </p:txBody>
@@ -8827,7 +8827,7 @@
                 </a:solidFill>
                 <a:latin typeface="Calibri"/>
               </a:rPr>
-              <a:t>Weekly update, live</a:t>
+              <a:t>Pick a job and go, live</a:t>
             </a:r>
           </a:p>
         </p:txBody>
@@ -8866,7 +8866,7 @@
                 </a:solidFill>
                 <a:latin typeface="Calibri"/>
               </a:rPr>
-              <a:t>•  Three context files: who-i-am.md, priorities.md, voice.md. Plus last week's evidence, pulled from Work IQ before the talk.</a:t>
+              <a:t>•  One prompt. It asks which job, then how you reach each kind of evidence: a connector like Work IQ, a paste, a file, or skip.</a:t>
             </a:r>
           </a:p>
           <a:p>
@@ -8882,7 +8882,7 @@
                 </a:solidFill>
                 <a:latin typeface="Calibri"/>
               </a:rPr>
-              <a:t>•  Every Done line has to cite a ticket, a meeting, or a message you can open.</a:t>
+              <a:t>•  It gathers one kind at a time and shows an inventory. Items with no link stay out of Done.</a:t>
             </a:r>
           </a:p>
           <a:p>
@@ -8898,7 +8898,7 @@
                 </a:solidFill>
                 <a:latin typeface="Calibri"/>
               </a:rPr>
-              <a:t>•  Copy the prompt from GitHub. Paste it with the files and the evidence into your editor. Run it.</a:t>
+              <a:t>•  Then it drafts in your voice and runs the check line by line. You click one link.</a:t>
             </a:r>
           </a:p>
         </p:txBody>
@@ -10037,7 +10037,7 @@
                 </a:solidFill>
                 <a:latin typeface="Calibri"/>
               </a:rPr>
-              <a:t>5 min</a:t>
+              <a:t>10 min</a:t>
             </a:r>
           </a:p>
         </p:txBody>
@@ -10072,7 +10072,7 @@
                 </a:solidFill>
                 <a:latin typeface="Calibri"/>
               </a:rPr>
-              <a:t>Pull last week: meetings, sent mail, work items. Ask Work IQ, or paste a list.</a:t>
+              <a:t>Paste guided-run.md and the three files. Pick weekly update. Answer its questions. Gather evidence the way it offers: connector, paste, or file.</a:t>
             </a:r>
           </a:p>
         </p:txBody>
@@ -10185,7 +10185,7 @@
                 </a:solidFill>
                 <a:latin typeface="Calibri"/>
               </a:rPr>
-              <a:t>Paste weekly-update.md, the three files, and the evidence into your tool. Run it.</a:t>
+              <a:t>Check every Done line against something you can open. No source? Cut it.</a:t>
             </a:r>
           </a:p>
         </p:txBody>
@@ -10298,119 +10298,6 @@
                 </a:solidFill>
                 <a:latin typeface="Calibri"/>
               </a:rPr>
-              <a:t>Check every Done line against something you can open. No source? Cut it.</a:t>
-            </a:r>
-          </a:p>
-        </p:txBody>
-      </p:sp>
-      <p:sp>
-        <p:nvSpPr>
-          <p:cNvPr id="18" name="Rectangle 17"/>
-          <p:cNvSpPr/>
-          <p:nvPr/>
-        </p:nvSpPr>
-        <p:spPr>
-          <a:xfrm>
-            <a:off x="731520" y="4754879"/>
-            <a:ext cx="10515600" cy="777240"/>
-          </a:xfrm>
-          <a:prstGeom prst="rect">
-            <a:avLst/>
-          </a:prstGeom>
-          <a:solidFill>
-            <a:srgbClr val="141414"/>
-          </a:solidFill>
-          <a:ln>
-            <a:noFill/>
-          </a:ln>
-        </p:spPr>
-        <p:style>
-          <a:lnRef idx="1">
-            <a:schemeClr val="accent1"/>
-          </a:lnRef>
-          <a:fillRef idx="3">
-            <a:schemeClr val="accent1"/>
-          </a:fillRef>
-          <a:effectRef idx="2">
-            <a:schemeClr val="accent1"/>
-          </a:effectRef>
-          <a:fontRef idx="minor">
-            <a:schemeClr val="lt1"/>
-          </a:fontRef>
-        </p:style>
-        <p:txBody>
-          <a:bodyPr rtlCol="0" anchor="ctr"/>
-          <a:lstStyle/>
-          <a:p>
-            <a:pPr algn="ctr"/>
-          </a:p>
-        </p:txBody>
-      </p:sp>
-      <p:sp>
-        <p:nvSpPr>
-          <p:cNvPr id="19" name="TextBox 18"/>
-          <p:cNvSpPr txBox="1"/>
-          <p:nvPr/>
-        </p:nvSpPr>
-        <p:spPr>
-          <a:xfrm>
-            <a:off x="960120" y="4937759"/>
-            <a:ext cx="1645920" cy="457200"/>
-          </a:xfrm>
-          <a:prstGeom prst="rect">
-            <a:avLst/>
-          </a:prstGeom>
-          <a:noFill/>
-        </p:spPr>
-        <p:txBody>
-          <a:bodyPr wrap="square">
-            <a:spAutoFit/>
-          </a:bodyPr>
-          <a:lstStyle/>
-          <a:p>
-            <a:pPr algn="l"/>
-            <a:r>
-              <a:rPr sz="1800" b="1">
-                <a:solidFill>
-                  <a:srgbClr val="B3995D"/>
-                </a:solidFill>
-                <a:latin typeface="Calibri"/>
-              </a:rPr>
-              <a:t>5 min</a:t>
-            </a:r>
-          </a:p>
-        </p:txBody>
-      </p:sp>
-      <p:sp>
-        <p:nvSpPr>
-          <p:cNvPr id="20" name="TextBox 19"/>
-          <p:cNvSpPr txBox="1"/>
-          <p:nvPr/>
-        </p:nvSpPr>
-        <p:spPr>
-          <a:xfrm>
-            <a:off x="2743200" y="4937759"/>
-            <a:ext cx="8321040" cy="548640"/>
-          </a:xfrm>
-          <a:prstGeom prst="rect">
-            <a:avLst/>
-          </a:prstGeom>
-          <a:noFill/>
-        </p:spPr>
-        <p:txBody>
-          <a:bodyPr wrap="square">
-            <a:spAutoFit/>
-          </a:bodyPr>
-          <a:lstStyle/>
-          <a:p>
-            <a:pPr algn="l"/>
-            <a:r>
-              <a:rPr sz="1700" b="0">
-                <a:solidFill>
-                  <a:srgbClr val="F4EBD0"/>
-                </a:solidFill>
-                <a:latin typeface="Calibri"/>
-              </a:rPr>
               <a:t>Wrong? Fix the prompt or a context file, not the chat. Run it again.</a:t>
             </a:r>
           </a:p>
@@ -10418,7 +10305,7 @@
       </p:sp>
       <p:sp>
         <p:nvSpPr>
-          <p:cNvPr id="21" name="TextBox 20"/>
+          <p:cNvPr id="18" name="TextBox 17"/>
           <p:cNvSpPr txBox="1"/>
           <p:nvPr/>
         </p:nvSpPr>
@@ -10453,7 +10340,7 @@
       </p:sp>
       <p:sp>
         <p:nvSpPr>
-          <p:cNvPr id="22" name="TextBox 21"/>
+          <p:cNvPr id="19" name="TextBox 18"/>
           <p:cNvSpPr txBox="1"/>
           <p:nvPr/>
         </p:nvSpPr>
@@ -10488,7 +10375,7 @@
       </p:sp>
       <p:sp>
         <p:nvSpPr>
-          <p:cNvPr id="23" name="TextBox 22"/>
+          <p:cNvPr id="20" name="TextBox 19"/>
           <p:cNvSpPr txBox="1"/>
           <p:nvPr/>
         </p:nvSpPr>

</xml_diff>

<commit_message>
Plain-language pass over slide text and notes.
Colons that joined clauses become sentences. Card labels on the edges
and levels slides are whole sentences. Rhetorical questions on the
Monday slide become statements. "CoS" is spelled out. "Door",
"territory", "glue", and "receipts" get their literal words.
</commit_message>
<xml_diff>
--- a/slides/building-your-own-chief-of-staff.pptx
+++ b/slides/building-your-own-chief-of-staff.pptx
@@ -518,7 +518,7 @@
           <a:p/>
           <a:p>
             <a:r>
-              <a:t>The Chief of Staff agent is the worked example. The weekly update is the file we run live.</a:t>
+              <a:t>The Chief of Staff agent is the worked example. The weekly update is the job we run live, with the room.</a:t>
             </a:r>
           </a:p>
           <a:p/>
@@ -700,7 +700,7 @@
           <a:p/>
           <a:p>
             <a:r>
-              <a:t>Sources, if they want receipts: https://github.com/BittahCriminal/build-your-own-chief-of-staff/blob/main/research/SOURCES.md</a:t>
+              <a:t>Sources, if they ask for them: https://github.com/BittahCriminal/build-your-own-chief-of-staff/blob/main/research/SOURCES.md</a:t>
             </a:r>
           </a:p>
           <a:p/>
@@ -782,13 +782,13 @@
           <a:p/>
           <a:p>
             <a:r>
-              <a:t>Repeatable, yes: the weekly update, same headings every Friday with new evidence. No: which of two candidates to hire.</a:t>
+              <a:t>Repeatable. The weekly update passes, same headings every Friday with new evidence. Choosing which of two candidates to hire fails.</a:t>
             </a:r>
           </a:p>
           <a:p/>
           <a:p>
             <a:r>
-              <a:t>Verifiable, yes: every Done line cites a ticket or a message you can open. No: "make it sound professional".</a:t>
+              <a:t>Verifiable. A Done line that cites a ticket or a message you can open passes. "Make it sound professional" fails.</a:t>
             </a:r>
           </a:p>
           <a:p/>
@@ -800,7 +800,7 @@
           <a:p/>
           <a:p>
             <a:r>
-              <a:t>If the room is stuck at an empty prompt: "handle my email" is seventeen jobs. Split it. The prompt for that is what-to-automate.md.</a:t>
+              <a:t>If the room is stuck at an empty prompt, say that "handle my email" is seventeen jobs, and split it. The prompt for that is what-to-automate.md.</a:t>
             </a:r>
           </a:p>
           <a:p/>
@@ -882,7 +882,7 @@
           <a:p/>
           <a:p>
             <a:r>
-              <a:t>The core is where people want help first and where first projects die. Automate around the craft, not through it.</a:t>
+              <a:t>The core is where people want help first and where first projects die. Automate the work around the craft, not the craft itself.</a:t>
             </a:r>
           </a:p>
           <a:p/>
@@ -964,19 +964,19 @@
           <a:lstStyle/>
           <a:p>
             <a:r>
-              <a:t>One minute. Left column: the portable jobs from the Delegation Kit, in operator English. Source: https://github.com/BittahCriminal/build-your-own-chief-of-staff/blob/main/research/notes/delegation-kit.md</a:t>
+              <a:t>One minute. The left column is the portable jobs from the Delegation Kit, in operator English. Source: https://github.com/BittahCriminal/build-your-own-chief-of-staff/blob/main/research/notes/delegation-kit.md</a:t>
             </a:r>
           </a:p>
           <a:p/>
           <a:p>
             <a:r>
-              <a:t>Right column is not "AI cannot do it". It is "checking it costs as much as doing it".</a:t>
+              <a:t>The right column is not "AI cannot do it". It is "checking it costs as much as doing it".</a:t>
             </a:r>
           </a:p>
           <a:p/>
           <a:p>
             <a:r>
-              <a:t>Flag the weekly update. Next slide leaves PowerPoint. You paste one prompt in your editor and it walks the room through the job.</a:t>
+              <a:t>Flag the weekly update. The next slide leaves PowerPoint. You paste one prompt in your editor and it walks the room through the job.</a:t>
             </a:r>
           </a:p>
         </p:txBody>
@@ -1046,7 +1046,7 @@
           <a:lstStyle/>
           <a:p>
             <a:r>
-              <a:t>One minute. Click the URL. Stay on the README. Point at the six names. Personal data never ships here; the templates are blanks.</a:t>
+              <a:t>One minute. Click the URL. Stay on the README. Point at the six names. Personal data never ships here. The templates are blanks.</a:t>
             </a:r>
           </a:p>
           <a:p/>
@@ -1058,7 +1058,7 @@
           <a:p/>
           <a:p>
             <a:r>
-              <a:t>Then the next slide. Do not open PROCESS.md yet.</a:t>
+              <a:t>Then go to the next slide. Do not open PROCESS.md yet.</a:t>
             </a:r>
           </a:p>
           <a:p/>
@@ -1134,7 +1134,7 @@
           <a:lstStyle/>
           <a:p>
             <a:r>
-              <a:t>Eight minutes. Leave PowerPoint. Show guided-run.md on GitHub for ten seconds, then the editor.</a:t>
+              <a:t>Eight minutes. Leave PowerPoint. Show guided-run.md on GitHub for ten seconds, then switch to the editor.</a:t>
             </a:r>
           </a:p>
           <a:p/>
@@ -1158,7 +1158,7 @@
           <a:p/>
           <a:p>
             <a:r>
-              <a:t>Approve the inventory. Read the draft. It runs the check. Click one link. If it invented something, say so. That is step 5 live. Ask it which file to fix.</a:t>
+              <a:t>Approve the inventory. Read the draft. It runs the check. Click one link. If it invented something, say so. That is step 5 happening live. Ask it which file to fix.</a:t>
             </a:r>
           </a:p>
           <a:p/>
@@ -1245,12 +1245,12 @@
           </a:p>
           <a:p>
             <a:r>
-              <a:t>2. Write the SOP. Inputs: three files plus evidence. Output: one screen. Check: every line cites something you can open.</a:t>
-            </a:r>
-          </a:p>
-          <a:p>
-            <a:r>
-              <a:t>3. Put you in files you own. who-i-am, priorities, voice. Swap the tool tomorrow and nothing moves.</a:t>
+              <a:t>2. Write the SOP. The inputs are three files plus the evidence. The output is one screen. The check is that every line cites something you can open.</a:t>
+            </a:r>
+          </a:p>
+          <a:p>
+            <a:r>
+              <a:t>3. Put you in files you own. Those files are who-i-am, priorities, and voice. Swap the tool tomorrow and nothing moves.</a:t>
             </a:r>
           </a:p>
           <a:p>
@@ -1276,13 +1276,13 @@
           <a:p/>
           <a:p>
             <a:r>
-              <a:t>Then: point the seven steps at expense reports, hiring screens, incident recaps. A smarter model skips none of this.</a:t>
+              <a:t>Then say the same seven steps apply to expense reports, hiring screens, and incident recaps. A smarter model skips none of them.</a:t>
             </a:r>
           </a:p>
           <a:p/>
           <a:p>
             <a:r>
-              <a:t>Back to the deck for Monday, the levels, and the close. The ranking card is score-the-candidates.md. Name it if someone has three ideas.</a:t>
+              <a:t>Go back to the deck for Monday, the levels, and the close. The ranking card is score-the-candidates.md. Name it if someone has three ideas.</a:t>
             </a:r>
           </a:p>
           <a:p/>
@@ -1358,7 +1358,7 @@
           <a:lstStyle/>
           <a:p>
             <a:r>
-              <a:t>One minute. The README start-here path, but the deliverable is one real update on their own week. The guided run asks for what it needs and stops if a file is missing. That is not a failure.</a:t>
+              <a:t>One minute. This is the README start-here path, but the deliverable is one real update on their own week. The guided run asks for what it needs and stops if a file is missing. That is not a failure.</a:t>
             </a:r>
           </a:p>
           <a:p/>
@@ -1370,7 +1370,7 @@
           <a:p/>
           <a:p>
             <a:r>
-              <a:t>No timer until they have checked three Fridays by hand.</a:t>
+              <a:t>Do not put it on a timer until they have checked three Fridays by hand.</a:t>
             </a:r>
           </a:p>
         </p:txBody>
@@ -1440,7 +1440,7 @@
           <a:lstStyle/>
           <a:p>
             <a:r>
-              <a:t>One minute. A map, not a step. Today sat on the second card: the agent drafted, a human read every line.</a:t>
+              <a:t>One minute. A map, not a step. Today sat on the second card. The agent drafted and a human read every line.</a:t>
             </a:r>
           </a:p>
           <a:p/>
@@ -1452,7 +1452,7 @@
           <a:p/>
           <a:p>
             <a:r>
-              <a:t>Levels 3 and 4 are platform-team territory. Name them. Do not sell them.</a:t>
+              <a:t>Levels 3 and 4 are platform-team work. Name them. Do not sell them.</a:t>
             </a:r>
           </a:p>
           <a:p/>
@@ -4695,7 +4695,7 @@
                 <a:latin typeface="Calibri"/>
               </a:rPr>
               <a:t>Teach the process, not a tool.
-Leave knowing how to build a CoS agent, and how to automate
+Leave knowing how to build a chief of staff agent, and how to automate
 anything that is repeatable and verifiable.</a:t>
             </a:r>
           </a:p>
@@ -5070,7 +5070,7 @@
                 </a:solidFill>
                 <a:latin typeface="Calibri"/>
               </a:rPr>
-              <a:t>•  Stale is visible. Silent omission is a lie.</a:t>
+              <a:t>•  Mark what is stale. Leaving it out is a lie.</a:t>
             </a:r>
           </a:p>
           <a:p>
@@ -5460,9 +5460,9 @@
                 </a:solidFill>
                 <a:latin typeface="Calibri"/>
               </a:rPr>
-              <a:t>Open START-HERE.md. Prompt kit, not the Claude plugin.
-The guided run, process files, CoS workflows, blank context templates, sample voices.
-Source notes live in research/SOURCES.md.</a:t>
+              <a:t>Open START-HERE.md. This is the prompt kit, not the Claude plugin.
+The guided run, the process files, the chief of staff workflows, blank context templates, and sample voices.
+The source notes are in research/SOURCES.md.</a:t>
             </a:r>
           </a:p>
         </p:txBody>
@@ -5930,7 +5930,7 @@
                 <a:latin typeface="Calibri"/>
               </a:rPr>
               <a:t>You would do the same steps next week.
-Same kinds of inputs. Same shape of output.
+The inputs are the same kind. The output is the same shape.
 Special cases every time is judgment.
 Keep it.</a:t>
             </a:r>
@@ -6370,7 +6370,7 @@
                 </a:solidFill>
                 <a:latin typeface="Calibri"/>
               </a:rPr>
-              <a:t>Collect, clean, reconcile</a:t>
+              <a:t>Collect, clean, and reconcile the inputs.</a:t>
             </a:r>
           </a:p>
         </p:txBody>
@@ -6483,7 +6483,7 @@
                 </a:solidFill>
                 <a:latin typeface="Calibri"/>
               </a:rPr>
-              <a:t>Completeness, obvious errors</a:t>
+              <a:t>Check for completeness and obvious errors.</a:t>
             </a:r>
           </a:p>
         </p:txBody>
@@ -6596,7 +6596,7 @@
                 </a:solidFill>
                 <a:latin typeface="Calibri"/>
               </a:rPr>
-              <a:t>A thread into one page</a:t>
+              <a:t>Turn a thread into one page.</a:t>
             </a:r>
           </a:p>
         </p:txBody>
@@ -6709,7 +6709,7 @@
                 </a:solidFill>
                 <a:latin typeface="Calibri"/>
               </a:rPr>
-              <a:t>Analysis into a brief or an update</a:t>
+              <a:t>Turn the analysis into a brief or an update.</a:t>
             </a:r>
           </a:p>
         </p:txBody>
@@ -6822,7 +6822,7 @@
                 </a:solidFill>
                 <a:latin typeface="Calibri"/>
               </a:rPr>
-              <a:t>Move context. Stop being the glue.</a:t>
+              <a:t>Move context between people. Stop carrying it by hand.</a:t>
             </a:r>
           </a:p>
         </p:txBody>
@@ -6858,7 +6858,7 @@
                 <a:latin typeface="Calibri"/>
               </a:rPr>
               <a:t>The core is craft. Taste, red lines, how a room lands. Protect it.
-Pick the simplest edge with the clearest lift, not the most impressive one.</a:t>
+Pick the simplest edge with the clearest gain, not the most impressive one.</a:t>
             </a:r>
           </a:p>
         </p:txBody>
@@ -7539,7 +7539,7 @@
                 </a:solidFill>
                 <a:latin typeface="Calibri"/>
               </a:rPr>
-              <a:t>The weekly update needs three context files, who you are, the quarter's priorities, and your voice, plus last week's evidence.</a:t>
+              <a:t>The weekly update needs three context files: who you are, the quarter's priorities, and your voice. Plus last week's evidence.</a:t>
             </a:r>
           </a:p>
         </p:txBody>
@@ -7990,7 +7990,7 @@
                 </a:solidFill>
                 <a:latin typeface="Calibri"/>
               </a:rPr>
-              <a:t>Same markdown. Copilot, Cursor, Claude, ChatGPT, or Gemini.
+              <a:t>The same markdown works in Copilot, Cursor, Claude, ChatGPT, and Gemini.
 Click the tree. Do not tour every file.</a:t>
             </a:r>
           </a:p>
@@ -8201,7 +8201,7 @@
                 </a:solidFill>
                 <a:latin typeface="Calibri"/>
               </a:rPr>
-              <a:t>The CoS jobs, ready to paste</a:t>
+              <a:t>The chief of staff jobs, ready to paste</a:t>
             </a:r>
           </a:p>
         </p:txBody>
@@ -8341,7 +8341,7 @@
                 </a:solidFill>
                 <a:latin typeface="Calibri"/>
               </a:rPr>
-              <a:t>Blanks. Copy privately. Fill them.</a:t>
+              <a:t>Blanks. Copy them privately and fill them in.</a:t>
             </a:r>
           </a:p>
         </p:txBody>
@@ -9959,7 +9959,7 @@
                 </a:solidFill>
                 <a:latin typeface="Calibri"/>
               </a:rPr>
-              <a:t>Copy context-templates to a private folder. Fill who-i-am.md, priorities.md, voice.md.</a:t>
+              <a:t>Copy context-templates to a private folder. Fill in who-i-am.md, priorities.md, and voice.md.</a:t>
             </a:r>
           </a:p>
         </p:txBody>
@@ -10185,7 +10185,7 @@
                 </a:solidFill>
                 <a:latin typeface="Calibri"/>
               </a:rPr>
-              <a:t>Check every Done line against something you can open. No source? Cut it.</a:t>
+              <a:t>Check every Done line against something you can open. A line with no source gets cut.</a:t>
             </a:r>
           </a:p>
         </p:txBody>
@@ -10298,7 +10298,7 @@
                 </a:solidFill>
                 <a:latin typeface="Calibri"/>
               </a:rPr>
-              <a:t>Wrong? Fix the prompt or a context file, not the chat. Run it again.</a:t>
+              <a:t>If the draft is wrong, fix the prompt or a context file, not the chat. Run it again.</a:t>
             </a:r>
           </a:p>
         </p:txBody>
@@ -10333,7 +10333,7 @@
                 </a:solidFill>
                 <a:latin typeface="Calibri"/>
               </a:rPr>
-              <a:t>Not sure what to automate next? what-to-automate.md. Left with three ideas? score-the-candidates.md.</a:t>
+              <a:t>If you do not know what to automate next, run what-to-automate.md. If you leave with three ideas, run score-the-candidates.md.</a:t>
             </a:r>
           </a:p>
         </p:txBody>
@@ -10953,7 +10953,7 @@
                 </a:solidFill>
                 <a:latin typeface="Calibri"/>
               </a:rPr>
-              <a:t>Limit: your review time.</a:t>
+              <a:t>Limited by your review time.</a:t>
             </a:r>
           </a:p>
         </p:txBody>
@@ -11137,7 +11137,7 @@
                 </a:solidFill>
                 <a:latin typeface="Calibri"/>
               </a:rPr>
-              <a:t>Limit: how hard your checks are.</a:t>
+              <a:t>Limited by how hard your checks are.</a:t>
             </a:r>
           </a:p>
         </p:txBody>
@@ -11321,7 +11321,7 @@
                 </a:solidFill>
                 <a:latin typeface="Calibri"/>
               </a:rPr>
-              <a:t>Limit: how good your rules are.</a:t>
+              <a:t>Limited by how good your rules are.</a:t>
             </a:r>
           </a:p>
         </p:txBody>
@@ -11505,7 +11505,7 @@
                 </a:solidFill>
                 <a:latin typeface="Calibri"/>
               </a:rPr>
-              <a:t>Limit: the whole system, not the model.</a:t>
+              <a:t>Limited by the whole system, not the model.</a:t>
             </a:r>
           </a:p>
         </p:txBody>
@@ -11540,7 +11540,7 @@
                 </a:solidFill>
                 <a:latin typeface="Calibri"/>
               </a:rPr>
-              <a:t>Everything today is Level 1. Step 7, schedule it, is the door to Level 2.</a:t>
+              <a:t>Everything today is Level 1. Step 7, schedule it, is the move to Level 2.</a:t>
             </a:r>
           </a:p>
         </p:txBody>
@@ -11575,7 +11575,7 @@
                 </a:solidFill>
                 <a:latin typeface="Calibri"/>
               </a:rPr>
-              <a:t>Do not walk through it until the check in your SOP is one a careful stranger could apply in a minute.
+              <a:t>Do not make that move until the check in your SOP is one a careful stranger could apply in a minute.
 A better model does not move you up a level. Better checks do.</a:t>
             </a:r>
           </a:p>

</xml_diff>